<commit_message>
Add region-based spatial attribution (patches grouped by facial landmarks)
The spatial feature y_s is a sum over the 256 patches as well as over layers and
queries, so the same exact decomposition yields per-patch and per-region shares.
Patches are grouped into eyes/nose/lips/skin/background using the 68 landmarks.

- exact per-region spatial attribution (additivity verified to 4e-16)
- FAKE driven by eye patches 47.7%; REAL by nose patches 55.7% (signed -0.640)
- cross-validates the query-space view (eyes 45.6% vs 47.7%) via an independent route
- branches read different regions: spatial favours eyes, temporal favours skin
- new finding: the nose FCG query is localised on the real face (86.2% own region)
  but drifts onto skin on the fake (9.1%), explaining the query/region discrepancy
- deck extended to 17 slides, layout re-validated
</commit_message>
<xml_diff>
--- a/results/DFD_FCG_Explainability.pptx
+++ b/results/DFD_FCG_Explainability.pptx
@@ -20,6 +20,8 @@
     <p:sldId id="268" r:id="rId19"/>
     <p:sldId id="269" r:id="rId20"/>
     <p:sldId id="270" r:id="rId21"/>
+    <p:sldId id="271" r:id="rId22"/>
+    <p:sldId id="272" r:id="rId23"/>
   </p:sldIdLst>
   <p:sldSz cx="12191695" cy="6858000" type="screen4x3"/>
   <p:notesSz cx="6858000" cy="9144000"/>
@@ -3909,7 +3911,7 @@
                 </a:solidFill>
                 <a:latin typeface="Segoe UI"/>
               </a:rPr>
-              <a:t>•  Each decision is split into a spatial vs temporal share, then into facial components, patches and encoder layers — all exactly.</a:t>
+              <a:t>•  Each decision is split — exactly — into a spatial vs temporal share, then into facial regions (patches around eyes / nose / lips / skin), patches and encoder layers.</a:t>
             </a:r>
           </a:p>
           <a:p>
@@ -4082,6 +4084,1054 @@
                 </a:solidFill>
                 <a:latin typeface="Segoe UI"/>
               </a:rPr>
+              <a:t>RESULT 5</a:t>
+            </a:r>
+          </a:p>
+        </p:txBody>
+      </p:sp>
+      <p:sp>
+        <p:nvSpPr>
+          <p:cNvPr id="4" name="TextBox 3"/>
+          <p:cNvSpPr txBox="1"/>
+          <p:nvPr/>
+        </p:nvSpPr>
+        <p:spPr>
+          <a:xfrm>
+            <a:off x="566928" y="548640"/>
+            <a:ext cx="11057839" cy="475488"/>
+          </a:xfrm>
+          <a:prstGeom prst="rect">
+            <a:avLst/>
+          </a:prstGeom>
+          <a:noFill/>
+        </p:spPr>
+        <p:txBody>
+          <a:bodyPr wrap="square" lIns="0" rIns="0" tIns="0" bIns="0">
+            <a:spAutoFit/>
+          </a:bodyPr>
+          <a:lstStyle/>
+          <a:p>
+            <a:pPr algn="l">
+              <a:lnSpc>
+                <a:spcPct val="114000"/>
+              </a:lnSpc>
+              <a:spcAft>
+                <a:spcPts val="500"/>
+              </a:spcAft>
+            </a:pPr>
+            <a:r>
+              <a:rPr sz="2500" b="1" i="0">
+                <a:solidFill>
+                  <a:srgbClr val="1C1C24"/>
+                </a:solidFill>
+                <a:latin typeface="Segoe UI"/>
+              </a:rPr>
+              <a:t>Zone attribution and component attention</a:t>
+            </a:r>
+          </a:p>
+        </p:txBody>
+      </p:sp>
+      <p:sp>
+        <p:nvSpPr>
+          <p:cNvPr id="5" name="TextBox 4"/>
+          <p:cNvSpPr txBox="1"/>
+          <p:nvPr/>
+        </p:nvSpPr>
+        <p:spPr>
+          <a:xfrm>
+            <a:off x="566928" y="1060704"/>
+            <a:ext cx="11057839" cy="310896"/>
+          </a:xfrm>
+          <a:prstGeom prst="rect">
+            <a:avLst/>
+          </a:prstGeom>
+          <a:noFill/>
+        </p:spPr>
+        <p:txBody>
+          <a:bodyPr wrap="square" lIns="0" rIns="0" tIns="0" bIns="0">
+            <a:spAutoFit/>
+          </a:bodyPr>
+          <a:lstStyle/>
+          <a:p>
+            <a:pPr algn="l">
+              <a:lnSpc>
+                <a:spcPct val="114000"/>
+              </a:lnSpc>
+              <a:spcAft>
+                <a:spcPts val="500"/>
+              </a:spcAft>
+            </a:pPr>
+            <a:r>
+              <a:rPr sz="1300" b="0" i="0">
+                <a:solidFill>
+                  <a:srgbClr val="5A5F6E"/>
+                </a:solidFill>
+                <a:latin typeface="Segoe UI"/>
+              </a:rPr>
+              <a:t>Area-normalising removes the advantage of physically large regions</a:t>
+            </a:r>
+          </a:p>
+        </p:txBody>
+      </p:sp>
+      <p:pic>
+        <p:nvPicPr>
+          <p:cNvPr id="6" name="Picture 5" descr="f6_zones.png"/>
+          <p:cNvPicPr>
+            <a:picLocks noChangeAspect="1"/>
+          </p:cNvPicPr>
+          <p:nvPr/>
+        </p:nvPicPr>
+        <p:blipFill>
+          <a:blip r:embed="rId2"/>
+          <a:stretch>
+            <a:fillRect/>
+          </a:stretch>
+        </p:blipFill>
+        <p:spPr>
+          <a:xfrm>
+            <a:off x="2364835" y="1554480"/>
+            <a:ext cx="7462024" cy="2514600"/>
+          </a:xfrm>
+          <a:prstGeom prst="rect">
+            <a:avLst/>
+          </a:prstGeom>
+        </p:spPr>
+      </p:pic>
+      <p:sp>
+        <p:nvSpPr>
+          <p:cNvPr id="7" name="TextBox 6"/>
+          <p:cNvSpPr txBox="1"/>
+          <p:nvPr/>
+        </p:nvSpPr>
+        <p:spPr>
+          <a:xfrm>
+            <a:off x="566928" y="4178808"/>
+            <a:ext cx="2057400" cy="2377440"/>
+          </a:xfrm>
+          <a:prstGeom prst="rect">
+            <a:avLst/>
+          </a:prstGeom>
+          <a:noFill/>
+        </p:spPr>
+        <p:txBody>
+          <a:bodyPr wrap="square" lIns="0" rIns="0" tIns="0" bIns="0">
+            <a:spAutoFit/>
+          </a:bodyPr>
+          <a:lstStyle/>
+          <a:p>
+            <a:pPr algn="l">
+              <a:lnSpc>
+                <a:spcPct val="122000"/>
+              </a:lnSpc>
+              <a:spcAft>
+                <a:spcPts val="500"/>
+              </a:spcAft>
+            </a:pPr>
+            <a:r>
+              <a:rPr sz="1100" b="0" i="0">
+                <a:solidFill>
+                  <a:srgbClr val="1C1C24"/>
+                </a:solidFill>
+                <a:latin typeface="Segoe UI"/>
+              </a:rPr>
+              <a:t>Sanity check on FCG:</a:t>
+            </a:r>
+          </a:p>
+          <a:p>
+            <a:pPr algn="l">
+              <a:lnSpc>
+                <a:spcPct val="122000"/>
+              </a:lnSpc>
+              <a:spcAft>
+                <a:spcPts val="500"/>
+              </a:spcAft>
+            </a:pPr>
+            <a:r>
+              <a:rPr sz="1100" b="0" i="0">
+                <a:solidFill>
+                  <a:srgbClr val="1C1C24"/>
+                </a:solidFill>
+                <a:latin typeface="Segoe UI"/>
+              </a:rPr>
+              <a:t>•  each of the four queries lands on its own region,</a:t>
+            </a:r>
+          </a:p>
+          <a:p>
+            <a:pPr algn="l">
+              <a:lnSpc>
+                <a:spcPct val="122000"/>
+              </a:lnSpc>
+              <a:spcAft>
+                <a:spcPts val="500"/>
+              </a:spcAft>
+            </a:pPr>
+            <a:r>
+              <a:rPr sz="1100" b="0" i="0">
+                <a:solidFill>
+                  <a:srgbClr val="1C1C24"/>
+                </a:solidFill>
+                <a:latin typeface="Segoe UI"/>
+              </a:rPr>
+              <a:t>•  so the component percentages are anatomically meaningful,</a:t>
+            </a:r>
+          </a:p>
+          <a:p>
+            <a:pPr algn="l">
+              <a:lnSpc>
+                <a:spcPct val="122000"/>
+              </a:lnSpc>
+              <a:spcAft>
+                <a:spcPts val="500"/>
+              </a:spcAft>
+            </a:pPr>
+            <a:r>
+              <a:rPr sz="1100" b="0" i="0">
+                <a:solidFill>
+                  <a:srgbClr val="1C1C24"/>
+                </a:solidFill>
+                <a:latin typeface="Segoe UI"/>
+              </a:rPr>
+              <a:t>•  not four anonymous channels.</a:t>
+            </a:r>
+          </a:p>
+        </p:txBody>
+      </p:sp>
+      <p:pic>
+        <p:nvPicPr>
+          <p:cNvPr id="8" name="Picture 7" descr="f8_attention.png"/>
+          <p:cNvPicPr>
+            <a:picLocks noChangeAspect="1"/>
+          </p:cNvPicPr>
+          <p:nvPr/>
+        </p:nvPicPr>
+        <p:blipFill>
+          <a:blip r:embed="rId3"/>
+          <a:stretch>
+            <a:fillRect/>
+          </a:stretch>
+        </p:blipFill>
+        <p:spPr>
+          <a:xfrm>
+            <a:off x="4991976" y="4178808"/>
+            <a:ext cx="4426991" cy="2386583"/>
+          </a:xfrm>
+          <a:prstGeom prst="rect">
+            <a:avLst/>
+          </a:prstGeom>
+        </p:spPr>
+      </p:pic>
+    </p:spTree>
+  </p:cSld>
+  <p:clrMapOvr>
+    <a:masterClrMapping/>
+  </p:clrMapOvr>
+</p:sld>
+</file>
+
+<file path=ppt/slides/slide11.xml><?xml version="1.0" encoding="utf-8"?>
+<p:sld xmlns:a="http://schemas.openxmlformats.org/drawingml/2006/main" xmlns:p="http://schemas.openxmlformats.org/presentationml/2006/main" xmlns:r="http://schemas.openxmlformats.org/officeDocument/2006/relationships">
+  <p:cSld>
+    <p:bg>
+      <p:bgPr>
+        <a:solidFill>
+          <a:srgbClr val="FFFFFF"/>
+        </a:solidFill>
+        <a:effectLst/>
+      </p:bgPr>
+    </p:bg>
+    <p:spTree>
+      <p:nvGrpSpPr>
+        <p:cNvPr id="1" name=""/>
+        <p:cNvGrpSpPr/>
+        <p:nvPr/>
+      </p:nvGrpSpPr>
+      <p:grpSpPr/>
+      <p:sp>
+        <p:nvSpPr>
+          <p:cNvPr id="2" name="Rectangle 1"/>
+          <p:cNvSpPr/>
+          <p:nvPr/>
+        </p:nvSpPr>
+        <p:spPr>
+          <a:xfrm>
+            <a:off x="0" y="0"/>
+            <a:ext cx="12191695" cy="77724"/>
+          </a:xfrm>
+          <a:prstGeom prst="rect">
+            <a:avLst/>
+          </a:prstGeom>
+          <a:solidFill>
+            <a:srgbClr val="2E6FD9"/>
+          </a:solidFill>
+          <a:ln>
+            <a:noFill/>
+          </a:ln>
+          <a:effectLst/>
+        </p:spPr>
+        <p:style>
+          <a:lnRef idx="1">
+            <a:schemeClr val="accent1"/>
+          </a:lnRef>
+          <a:fillRef idx="3">
+            <a:schemeClr val="accent1"/>
+          </a:fillRef>
+          <a:effectRef idx="2">
+            <a:schemeClr val="accent1"/>
+          </a:effectRef>
+          <a:fontRef idx="minor">
+            <a:schemeClr val="lt1"/>
+          </a:fontRef>
+        </p:style>
+        <p:txBody>
+          <a:bodyPr rtlCol="0" anchor="ctr"/>
+          <a:lstStyle/>
+          <a:p>
+            <a:pPr algn="ctr"/>
+          </a:p>
+        </p:txBody>
+      </p:sp>
+      <p:sp>
+        <p:nvSpPr>
+          <p:cNvPr id="3" name="TextBox 2"/>
+          <p:cNvSpPr txBox="1"/>
+          <p:nvPr/>
+        </p:nvSpPr>
+        <p:spPr>
+          <a:xfrm>
+            <a:off x="566928" y="274320"/>
+            <a:ext cx="11057839" cy="237744"/>
+          </a:xfrm>
+          <a:prstGeom prst="rect">
+            <a:avLst/>
+          </a:prstGeom>
+          <a:noFill/>
+        </p:spPr>
+        <p:txBody>
+          <a:bodyPr wrap="square" lIns="0" rIns="0" tIns="0" bIns="0">
+            <a:spAutoFit/>
+          </a:bodyPr>
+          <a:lstStyle/>
+          <a:p>
+            <a:pPr algn="l">
+              <a:lnSpc>
+                <a:spcPct val="114000"/>
+              </a:lnSpc>
+              <a:spcAft>
+                <a:spcPts val="500"/>
+              </a:spcAft>
+            </a:pPr>
+            <a:r>
+              <a:rPr sz="1100" b="1" i="0">
+                <a:solidFill>
+                  <a:srgbClr val="2E6FD9"/>
+                </a:solidFill>
+                <a:latin typeface="Segoe UI"/>
+              </a:rPr>
+              <a:t>RESULT 6</a:t>
+            </a:r>
+          </a:p>
+        </p:txBody>
+      </p:sp>
+      <p:sp>
+        <p:nvSpPr>
+          <p:cNvPr id="4" name="TextBox 3"/>
+          <p:cNvSpPr txBox="1"/>
+          <p:nvPr/>
+        </p:nvSpPr>
+        <p:spPr>
+          <a:xfrm>
+            <a:off x="566928" y="548640"/>
+            <a:ext cx="11057839" cy="475488"/>
+          </a:xfrm>
+          <a:prstGeom prst="rect">
+            <a:avLst/>
+          </a:prstGeom>
+          <a:noFill/>
+        </p:spPr>
+        <p:txBody>
+          <a:bodyPr wrap="square" lIns="0" rIns="0" tIns="0" bIns="0">
+            <a:spAutoFit/>
+          </a:bodyPr>
+          <a:lstStyle/>
+          <a:p>
+            <a:pPr algn="l">
+              <a:lnSpc>
+                <a:spcPct val="114000"/>
+              </a:lnSpc>
+              <a:spcAft>
+                <a:spcPts val="500"/>
+              </a:spcAft>
+            </a:pPr>
+            <a:r>
+              <a:rPr sz="2500" b="1" i="0">
+                <a:solidFill>
+                  <a:srgbClr val="1C1C24"/>
+                </a:solidFill>
+                <a:latin typeface="Segoe UI"/>
+              </a:rPr>
+              <a:t>Is one branch enough?</a:t>
+            </a:r>
+          </a:p>
+        </p:txBody>
+      </p:sp>
+      <p:sp>
+        <p:nvSpPr>
+          <p:cNvPr id="5" name="TextBox 4"/>
+          <p:cNvSpPr txBox="1"/>
+          <p:nvPr/>
+        </p:nvSpPr>
+        <p:spPr>
+          <a:xfrm>
+            <a:off x="566928" y="1060704"/>
+            <a:ext cx="11057839" cy="310896"/>
+          </a:xfrm>
+          <a:prstGeom prst="rect">
+            <a:avLst/>
+          </a:prstGeom>
+          <a:noFill/>
+        </p:spPr>
+        <p:txBody>
+          <a:bodyPr wrap="square" lIns="0" rIns="0" tIns="0" bIns="0">
+            <a:spAutoFit/>
+          </a:bodyPr>
+          <a:lstStyle/>
+          <a:p>
+            <a:pPr algn="l">
+              <a:lnSpc>
+                <a:spcPct val="114000"/>
+              </a:lnSpc>
+              <a:spcAft>
+                <a:spcPts val="500"/>
+              </a:spcAft>
+            </a:pPr>
+            <a:r>
+              <a:rPr sz="1300" b="0" i="0">
+                <a:solidFill>
+                  <a:srgbClr val="5A5F6E"/>
+                </a:solidFill>
+                <a:latin typeface="Segoe UI"/>
+              </a:rPr>
+              <a:t>Inference-time ablation of the released checkpoint</a:t>
+            </a:r>
+          </a:p>
+        </p:txBody>
+      </p:sp>
+      <p:pic>
+        <p:nvPicPr>
+          <p:cNvPr id="6" name="Picture 5" descr="f9_counterfactual.png"/>
+          <p:cNvPicPr>
+            <a:picLocks noChangeAspect="1"/>
+          </p:cNvPicPr>
+          <p:nvPr/>
+        </p:nvPicPr>
+        <p:blipFill>
+          <a:blip r:embed="rId2"/>
+          <a:stretch>
+            <a:fillRect/>
+          </a:stretch>
+        </p:blipFill>
+        <p:spPr>
+          <a:xfrm>
+            <a:off x="566928" y="1554480"/>
+            <a:ext cx="7315200" cy="2414986"/>
+          </a:xfrm>
+          <a:prstGeom prst="rect">
+            <a:avLst/>
+          </a:prstGeom>
+        </p:spPr>
+      </p:pic>
+      <p:sp>
+        <p:nvSpPr>
+          <p:cNvPr id="7" name="Rounded Rectangle 6"/>
+          <p:cNvSpPr/>
+          <p:nvPr/>
+        </p:nvSpPr>
+        <p:spPr>
+          <a:xfrm>
+            <a:off x="8092440" y="1554480"/>
+            <a:ext cx="3529584" cy="1170432"/>
+          </a:xfrm>
+          <a:prstGeom prst="roundRect">
+            <a:avLst/>
+          </a:prstGeom>
+          <a:solidFill>
+            <a:srgbClr val="F2F4F8"/>
+          </a:solidFill>
+          <a:ln w="15240">
+            <a:solidFill>
+              <a:srgbClr val="1E7A3C"/>
+            </a:solidFill>
+          </a:ln>
+          <a:effectLst/>
+        </p:spPr>
+        <p:style>
+          <a:lnRef idx="1">
+            <a:schemeClr val="accent1"/>
+          </a:lnRef>
+          <a:fillRef idx="3">
+            <a:schemeClr val="accent1"/>
+          </a:fillRef>
+          <a:effectRef idx="2">
+            <a:schemeClr val="accent1"/>
+          </a:effectRef>
+          <a:fontRef idx="minor">
+            <a:schemeClr val="lt1"/>
+          </a:fontRef>
+        </p:style>
+        <p:txBody>
+          <a:bodyPr rtlCol="0" anchor="ctr"/>
+          <a:lstStyle/>
+          <a:p>
+            <a:pPr algn="ctr"/>
+          </a:p>
+        </p:txBody>
+      </p:sp>
+      <p:sp>
+        <p:nvSpPr>
+          <p:cNvPr id="8" name="TextBox 7"/>
+          <p:cNvSpPr txBox="1"/>
+          <p:nvPr/>
+        </p:nvSpPr>
+        <p:spPr>
+          <a:xfrm>
+            <a:off x="8275319" y="1682496"/>
+            <a:ext cx="3163824" cy="237744"/>
+          </a:xfrm>
+          <a:prstGeom prst="rect">
+            <a:avLst/>
+          </a:prstGeom>
+          <a:noFill/>
+        </p:spPr>
+        <p:txBody>
+          <a:bodyPr wrap="square" lIns="0" rIns="0" tIns="0" bIns="0">
+            <a:spAutoFit/>
+          </a:bodyPr>
+          <a:lstStyle/>
+          <a:p>
+            <a:pPr algn="l">
+              <a:lnSpc>
+                <a:spcPct val="114000"/>
+              </a:lnSpc>
+              <a:spcAft>
+                <a:spcPts val="500"/>
+              </a:spcAft>
+            </a:pPr>
+            <a:r>
+              <a:rPr sz="1000" b="1" i="0">
+                <a:solidFill>
+                  <a:srgbClr val="5A5F6E"/>
+                </a:solidFill>
+                <a:latin typeface="Segoe UI"/>
+              </a:rPr>
+              <a:t>FAKE SAMPLE</a:t>
+            </a:r>
+          </a:p>
+        </p:txBody>
+      </p:sp>
+      <p:sp>
+        <p:nvSpPr>
+          <p:cNvPr id="9" name="TextBox 8"/>
+          <p:cNvSpPr txBox="1"/>
+          <p:nvPr/>
+        </p:nvSpPr>
+        <p:spPr>
+          <a:xfrm>
+            <a:off x="8275319" y="1920240"/>
+            <a:ext cx="3163824" cy="384048"/>
+          </a:xfrm>
+          <a:prstGeom prst="rect">
+            <a:avLst/>
+          </a:prstGeom>
+          <a:noFill/>
+        </p:spPr>
+        <p:txBody>
+          <a:bodyPr wrap="square" lIns="0" rIns="0" tIns="0" bIns="0">
+            <a:spAutoFit/>
+          </a:bodyPr>
+          <a:lstStyle/>
+          <a:p>
+            <a:pPr algn="l">
+              <a:lnSpc>
+                <a:spcPct val="114000"/>
+              </a:lnSpc>
+              <a:spcAft>
+                <a:spcPts val="500"/>
+              </a:spcAft>
+            </a:pPr>
+            <a:r>
+              <a:rPr sz="1600" b="1" i="0">
+                <a:solidFill>
+                  <a:srgbClr val="1E7A3C"/>
+                </a:solidFill>
+                <a:latin typeface="Segoe UI"/>
+              </a:rPr>
+              <a:t>both sufficient</a:t>
+            </a:r>
+          </a:p>
+        </p:txBody>
+      </p:sp>
+      <p:sp>
+        <p:nvSpPr>
+          <p:cNvPr id="10" name="TextBox 9"/>
+          <p:cNvSpPr txBox="1"/>
+          <p:nvPr/>
+        </p:nvSpPr>
+        <p:spPr>
+          <a:xfrm>
+            <a:off x="8275319" y="2359152"/>
+            <a:ext cx="3163824" cy="256032"/>
+          </a:xfrm>
+          <a:prstGeom prst="rect">
+            <a:avLst/>
+          </a:prstGeom>
+          <a:noFill/>
+        </p:spPr>
+        <p:txBody>
+          <a:bodyPr wrap="square" lIns="0" rIns="0" tIns="0" bIns="0">
+            <a:spAutoFit/>
+          </a:bodyPr>
+          <a:lstStyle/>
+          <a:p>
+            <a:pPr algn="l">
+              <a:lnSpc>
+                <a:spcPct val="118000"/>
+              </a:lnSpc>
+              <a:spcAft>
+                <a:spcPts val="500"/>
+              </a:spcAft>
+            </a:pPr>
+            <a:r>
+              <a:rPr sz="1050" b="0" i="0">
+                <a:solidFill>
+                  <a:srgbClr val="1C1C24"/>
+                </a:solidFill>
+                <a:latin typeface="Segoe UI"/>
+              </a:rPr>
+              <a:t>S alone 0.912  ·  T alone 0.908</a:t>
+            </a:r>
+          </a:p>
+        </p:txBody>
+      </p:sp>
+      <p:sp>
+        <p:nvSpPr>
+          <p:cNvPr id="11" name="Rounded Rectangle 10"/>
+          <p:cNvSpPr/>
+          <p:nvPr/>
+        </p:nvSpPr>
+        <p:spPr>
+          <a:xfrm>
+            <a:off x="8092440" y="2889504"/>
+            <a:ext cx="3529584" cy="1170432"/>
+          </a:xfrm>
+          <a:prstGeom prst="roundRect">
+            <a:avLst/>
+          </a:prstGeom>
+          <a:solidFill>
+            <a:srgbClr val="F2F4F8"/>
+          </a:solidFill>
+          <a:ln w="15240">
+            <a:solidFill>
+              <a:srgbClr val="2E6FD9"/>
+            </a:solidFill>
+          </a:ln>
+          <a:effectLst/>
+        </p:spPr>
+        <p:style>
+          <a:lnRef idx="1">
+            <a:schemeClr val="accent1"/>
+          </a:lnRef>
+          <a:fillRef idx="3">
+            <a:schemeClr val="accent1"/>
+          </a:fillRef>
+          <a:effectRef idx="2">
+            <a:schemeClr val="accent1"/>
+          </a:effectRef>
+          <a:fontRef idx="minor">
+            <a:schemeClr val="lt1"/>
+          </a:fontRef>
+        </p:style>
+        <p:txBody>
+          <a:bodyPr rtlCol="0" anchor="ctr"/>
+          <a:lstStyle/>
+          <a:p>
+            <a:pPr algn="ctr"/>
+          </a:p>
+        </p:txBody>
+      </p:sp>
+      <p:sp>
+        <p:nvSpPr>
+          <p:cNvPr id="12" name="TextBox 11"/>
+          <p:cNvSpPr txBox="1"/>
+          <p:nvPr/>
+        </p:nvSpPr>
+        <p:spPr>
+          <a:xfrm>
+            <a:off x="8275319" y="3017520"/>
+            <a:ext cx="3163824" cy="237744"/>
+          </a:xfrm>
+          <a:prstGeom prst="rect">
+            <a:avLst/>
+          </a:prstGeom>
+          <a:noFill/>
+        </p:spPr>
+        <p:txBody>
+          <a:bodyPr wrap="square" lIns="0" rIns="0" tIns="0" bIns="0">
+            <a:spAutoFit/>
+          </a:bodyPr>
+          <a:lstStyle/>
+          <a:p>
+            <a:pPr algn="l">
+              <a:lnSpc>
+                <a:spcPct val="114000"/>
+              </a:lnSpc>
+              <a:spcAft>
+                <a:spcPts val="500"/>
+              </a:spcAft>
+            </a:pPr>
+            <a:r>
+              <a:rPr sz="1000" b="1" i="0">
+                <a:solidFill>
+                  <a:srgbClr val="5A5F6E"/>
+                </a:solidFill>
+                <a:latin typeface="Segoe UI"/>
+              </a:rPr>
+              <a:t>REAL SAMPLE</a:t>
+            </a:r>
+          </a:p>
+        </p:txBody>
+      </p:sp>
+      <p:sp>
+        <p:nvSpPr>
+          <p:cNvPr id="13" name="TextBox 12"/>
+          <p:cNvSpPr txBox="1"/>
+          <p:nvPr/>
+        </p:nvSpPr>
+        <p:spPr>
+          <a:xfrm>
+            <a:off x="8275319" y="3255264"/>
+            <a:ext cx="3163824" cy="384048"/>
+          </a:xfrm>
+          <a:prstGeom prst="rect">
+            <a:avLst/>
+          </a:prstGeom>
+          <a:noFill/>
+        </p:spPr>
+        <p:txBody>
+          <a:bodyPr wrap="square" lIns="0" rIns="0" tIns="0" bIns="0">
+            <a:spAutoFit/>
+          </a:bodyPr>
+          <a:lstStyle/>
+          <a:p>
+            <a:pPr algn="l">
+              <a:lnSpc>
+                <a:spcPct val="114000"/>
+              </a:lnSpc>
+              <a:spcAft>
+                <a:spcPts val="500"/>
+              </a:spcAft>
+            </a:pPr>
+            <a:r>
+              <a:rPr sz="1600" b="1" i="0">
+                <a:solidFill>
+                  <a:srgbClr val="2E6FD9"/>
+                </a:solidFill>
+                <a:latin typeface="Segoe UI"/>
+              </a:rPr>
+              <a:t>both sufficient</a:t>
+            </a:r>
+          </a:p>
+        </p:txBody>
+      </p:sp>
+      <p:sp>
+        <p:nvSpPr>
+          <p:cNvPr id="14" name="TextBox 13"/>
+          <p:cNvSpPr txBox="1"/>
+          <p:nvPr/>
+        </p:nvSpPr>
+        <p:spPr>
+          <a:xfrm>
+            <a:off x="8275319" y="3694176"/>
+            <a:ext cx="3163824" cy="256032"/>
+          </a:xfrm>
+          <a:prstGeom prst="rect">
+            <a:avLst/>
+          </a:prstGeom>
+          <a:noFill/>
+        </p:spPr>
+        <p:txBody>
+          <a:bodyPr wrap="square" lIns="0" rIns="0" tIns="0" bIns="0">
+            <a:spAutoFit/>
+          </a:bodyPr>
+          <a:lstStyle/>
+          <a:p>
+            <a:pPr algn="l">
+              <a:lnSpc>
+                <a:spcPct val="118000"/>
+              </a:lnSpc>
+              <a:spcAft>
+                <a:spcPts val="500"/>
+              </a:spcAft>
+            </a:pPr>
+            <a:r>
+              <a:rPr sz="1050" b="0" i="0">
+                <a:solidFill>
+                  <a:srgbClr val="1C1C24"/>
+                </a:solidFill>
+                <a:latin typeface="Segoe UI"/>
+              </a:rPr>
+              <a:t>S alone 0.469  ·  T alone 0.411</a:t>
+            </a:r>
+          </a:p>
+        </p:txBody>
+      </p:sp>
+      <p:sp>
+        <p:nvSpPr>
+          <p:cNvPr id="15" name="TextBox 14"/>
+          <p:cNvSpPr txBox="1"/>
+          <p:nvPr/>
+        </p:nvSpPr>
+        <p:spPr>
+          <a:xfrm>
+            <a:off x="8092440" y="4224528"/>
+            <a:ext cx="3529584" cy="822960"/>
+          </a:xfrm>
+          <a:prstGeom prst="rect">
+            <a:avLst/>
+          </a:prstGeom>
+          <a:noFill/>
+        </p:spPr>
+        <p:txBody>
+          <a:bodyPr wrap="square" lIns="0" rIns="0" tIns="0" bIns="0">
+            <a:spAutoFit/>
+          </a:bodyPr>
+          <a:lstStyle/>
+          <a:p>
+            <a:pPr algn="l">
+              <a:lnSpc>
+                <a:spcPct val="122000"/>
+              </a:lnSpc>
+              <a:spcAft>
+                <a:spcPts val="500"/>
+              </a:spcAft>
+            </a:pPr>
+            <a:r>
+              <a:rPr sz="1150" b="0" i="0">
+                <a:solidFill>
+                  <a:srgbClr val="1C1C24"/>
+                </a:solidFill>
+                <a:latin typeface="Segoe UI"/>
+              </a:rPr>
+              <a:t>Per-clip branch agreement:</a:t>
+            </a:r>
+          </a:p>
+          <a:p>
+            <a:pPr algn="l">
+              <a:lnSpc>
+                <a:spcPct val="122000"/>
+              </a:lnSpc>
+              <a:spcAft>
+                <a:spcPts val="500"/>
+              </a:spcAft>
+            </a:pPr>
+            <a:r>
+              <a:rPr sz="1150" b="0" i="0">
+                <a:solidFill>
+                  <a:srgbClr val="1C1C24"/>
+                </a:solidFill>
+                <a:latin typeface="Segoe UI"/>
+              </a:rPr>
+              <a:t>•  fake: 100%     - real: 87%</a:t>
+            </a:r>
+          </a:p>
+        </p:txBody>
+      </p:sp>
+      <p:sp>
+        <p:nvSpPr>
+          <p:cNvPr id="16" name="TextBox 15"/>
+          <p:cNvSpPr txBox="1"/>
+          <p:nvPr/>
+        </p:nvSpPr>
+        <p:spPr>
+          <a:xfrm>
+            <a:off x="566928" y="4134058"/>
+            <a:ext cx="7315200" cy="1463040"/>
+          </a:xfrm>
+          <a:prstGeom prst="rect">
+            <a:avLst/>
+          </a:prstGeom>
+          <a:noFill/>
+        </p:spPr>
+        <p:txBody>
+          <a:bodyPr wrap="square" lIns="0" rIns="0" tIns="0" bIns="0">
+            <a:spAutoFit/>
+          </a:bodyPr>
+          <a:lstStyle/>
+          <a:p>
+            <a:pPr algn="l">
+              <a:lnSpc>
+                <a:spcPct val="126000"/>
+              </a:lnSpc>
+              <a:spcAft>
+                <a:spcPts val="500"/>
+              </a:spcAft>
+            </a:pPr>
+            <a:r>
+              <a:rPr sz="1150" b="0" i="0">
+                <a:solidFill>
+                  <a:srgbClr val="1C1C24"/>
+                </a:solidFill>
+                <a:latin typeface="Segoe UI"/>
+              </a:rPr>
+              <a:t>•  On clean video either branch alone already reaches the correct verdict — the two are redundant here, not complementary.</a:t>
+            </a:r>
+          </a:p>
+          <a:p>
+            <a:pPr algn="l">
+              <a:lnSpc>
+                <a:spcPct val="126000"/>
+              </a:lnSpc>
+              <a:spcAft>
+                <a:spcPts val="500"/>
+              </a:spcAft>
+            </a:pPr>
+            <a:r>
+              <a:rPr sz="1150" b="0" i="0">
+                <a:solidFill>
+                  <a:srgbClr val="1C1C24"/>
+                </a:solidFill>
+                <a:latin typeface="Segoe UI"/>
+              </a:rPr>
+              <a:t>•  Fusion still adds confidence: the fake rises 0.91 → 0.93.</a:t>
+            </a:r>
+          </a:p>
+          <a:p>
+            <a:pPr algn="l">
+              <a:lnSpc>
+                <a:spcPct val="126000"/>
+              </a:lnSpc>
+              <a:spcAft>
+                <a:spcPts val="500"/>
+              </a:spcAft>
+            </a:pPr>
+            <a:r>
+              <a:rPr sz="1150" b="0" i="0">
+                <a:solidFill>
+                  <a:srgbClr val="1C1C24"/>
+                </a:solidFill>
+                <a:latin typeface="Segoe UI"/>
+              </a:rPr>
+              <a:t>•  That redundancy is exactly what breaks under degradation (next slide).</a:t>
+            </a:r>
+          </a:p>
+        </p:txBody>
+      </p:sp>
+    </p:spTree>
+  </p:cSld>
+  <p:clrMapOvr>
+    <a:masterClrMapping/>
+  </p:clrMapOvr>
+</p:sld>
+</file>
+
+<file path=ppt/slides/slide12.xml><?xml version="1.0" encoding="utf-8"?>
+<p:sld xmlns:a="http://schemas.openxmlformats.org/drawingml/2006/main" xmlns:p="http://schemas.openxmlformats.org/presentationml/2006/main" xmlns:r="http://schemas.openxmlformats.org/officeDocument/2006/relationships">
+  <p:cSld>
+    <p:bg>
+      <p:bgPr>
+        <a:solidFill>
+          <a:srgbClr val="FFFFFF"/>
+        </a:solidFill>
+        <a:effectLst/>
+      </p:bgPr>
+    </p:bg>
+    <p:spTree>
+      <p:nvGrpSpPr>
+        <p:cNvPr id="1" name=""/>
+        <p:cNvGrpSpPr/>
+        <p:nvPr/>
+      </p:nvGrpSpPr>
+      <p:grpSpPr/>
+      <p:sp>
+        <p:nvSpPr>
+          <p:cNvPr id="2" name="Rectangle 1"/>
+          <p:cNvSpPr/>
+          <p:nvPr/>
+        </p:nvSpPr>
+        <p:spPr>
+          <a:xfrm>
+            <a:off x="0" y="0"/>
+            <a:ext cx="12191695" cy="77724"/>
+          </a:xfrm>
+          <a:prstGeom prst="rect">
+            <a:avLst/>
+          </a:prstGeom>
+          <a:solidFill>
+            <a:srgbClr val="2E6FD9"/>
+          </a:solidFill>
+          <a:ln>
+            <a:noFill/>
+          </a:ln>
+          <a:effectLst/>
+        </p:spPr>
+        <p:style>
+          <a:lnRef idx="1">
+            <a:schemeClr val="accent1"/>
+          </a:lnRef>
+          <a:fillRef idx="3">
+            <a:schemeClr val="accent1"/>
+          </a:fillRef>
+          <a:effectRef idx="2">
+            <a:schemeClr val="accent1"/>
+          </a:effectRef>
+          <a:fontRef idx="minor">
+            <a:schemeClr val="lt1"/>
+          </a:fontRef>
+        </p:style>
+        <p:txBody>
+          <a:bodyPr rtlCol="0" anchor="ctr"/>
+          <a:lstStyle/>
+          <a:p>
+            <a:pPr algn="ctr"/>
+          </a:p>
+        </p:txBody>
+      </p:sp>
+      <p:sp>
+        <p:nvSpPr>
+          <p:cNvPr id="3" name="TextBox 2"/>
+          <p:cNvSpPr txBox="1"/>
+          <p:nvPr/>
+        </p:nvSpPr>
+        <p:spPr>
+          <a:xfrm>
+            <a:off x="566928" y="274320"/>
+            <a:ext cx="11057839" cy="237744"/>
+          </a:xfrm>
+          <a:prstGeom prst="rect">
+            <a:avLst/>
+          </a:prstGeom>
+          <a:noFill/>
+        </p:spPr>
+        <p:txBody>
+          <a:bodyPr wrap="square" lIns="0" rIns="0" tIns="0" bIns="0">
+            <a:spAutoFit/>
+          </a:bodyPr>
+          <a:lstStyle/>
+          <a:p>
+            <a:pPr algn="l">
+              <a:lnSpc>
+                <a:spcPct val="114000"/>
+              </a:lnSpc>
+              <a:spcAft>
+                <a:spcPts val="500"/>
+              </a:spcAft>
+            </a:pPr>
+            <a:r>
+              <a:rPr sz="1100" b="1" i="0">
+                <a:solidFill>
+                  <a:srgbClr val="2E6FD9"/>
+                </a:solidFill>
+                <a:latin typeface="Segoe UI"/>
+              </a:rPr>
               <a:t>RESULT 7</a:t>
             </a:r>
           </a:p>
@@ -4283,7 +5333,7 @@
 </p:sld>
 </file>
 
-<file path=ppt/slides/slide11.xml><?xml version="1.0" encoding="utf-8"?>
+<file path=ppt/slides/slide13.xml><?xml version="1.0" encoding="utf-8"?>
 <p:sld xmlns:a="http://schemas.openxmlformats.org/drawingml/2006/main" xmlns:p="http://schemas.openxmlformats.org/presentationml/2006/main" xmlns:r="http://schemas.openxmlformats.org/officeDocument/2006/relationships">
   <p:cSld>
     <p:bg>
@@ -5252,7 +6302,7 @@
 </p:sld>
 </file>
 
-<file path=ppt/slides/slide12.xml><?xml version="1.0" encoding="utf-8"?>
+<file path=ppt/slides/slide14.xml><?xml version="1.0" encoding="utf-8"?>
 <p:sld xmlns:a="http://schemas.openxmlformats.org/drawingml/2006/main" xmlns:p="http://schemas.openxmlformats.org/presentationml/2006/main" xmlns:r="http://schemas.openxmlformats.org/officeDocument/2006/relationships">
   <p:cSld>
     <p:bg>
@@ -9270,7 +10320,7 @@
 </p:sld>
 </file>
 
-<file path=ppt/slides/slide13.xml><?xml version="1.0" encoding="utf-8"?>
+<file path=ppt/slides/slide15.xml><?xml version="1.0" encoding="utf-8"?>
 <p:sld xmlns:a="http://schemas.openxmlformats.org/drawingml/2006/main" xmlns:p="http://schemas.openxmlformats.org/presentationml/2006/main" xmlns:r="http://schemas.openxmlformats.org/officeDocument/2006/relationships">
   <p:cSld>
     <p:bg>
@@ -9583,7 +10633,7 @@
                 </a:solidFill>
                 <a:latin typeface="Segoe UI"/>
               </a:rPr>
-              <a:t>MAIN CAUSE: the EYES — 45.6% of the spatial evidence, then skin 27.1%.</a:t>
+              <a:t>MAIN CAUSE: the EYES. By face region 47.7% of the spatial evidence; by the model's own query 45.6%. Two independent methods agree.</a:t>
             </a:r>
           </a:p>
           <a:p>
@@ -9602,7 +10652,7 @@
                 </a:solidFill>
                 <a:latin typeface="Segoe UI"/>
               </a:rPr>
-              <a:t>Temporal evidence appears in the inner face (eyes, nose) — the region the swap replaced.</a:t>
+              <a:t>Second is skin (33.0%), which is also where the temporal branch looks (41.9%).</a:t>
             </a:r>
           </a:p>
           <a:p>
@@ -9812,7 +10862,7 @@
                 </a:solidFill>
                 <a:latin typeface="Segoe UI"/>
               </a:rPr>
-              <a:t>Within the spatial branch the nose is the strongest REAL vote (-0.601, 60.3%).</a:t>
+              <a:t>Within the spatial branch the NOSE patches dominate (55.7%) and vote REAL (-0.640).</a:t>
             </a:r>
           </a:p>
           <a:p>
@@ -9892,7 +10942,7 @@
                 </a:solidFill>
                 <a:latin typeface="Segoe UI"/>
               </a:rPr>
-              <a:t>•  Fake detection is driven by the EYES; authenticity is confirmed by MOTION CONSISTENCY — the two verdicts are not mirror images.</a:t>
+              <a:t>•  Fake detection is driven by the EYES (47.7% of spatial evidence); authenticity is confirmed by MOTION CONSISTENCY (70.9%) — the two verdicts are not mirror images.</a:t>
             </a:r>
           </a:p>
           <a:p>
@@ -9911,7 +10961,7 @@
                 </a:solidFill>
                 <a:latin typeface="Segoe UI"/>
               </a:rPr>
-              <a:t>•  The spatial branch reads deep semantic layers, the temporal branch also reads shallow texture layers, so the frozen encoder is genuinely used at two depths.</a:t>
+              <a:t>•  The two branches look at different regions (spatial → eyes, temporal → skin), so they are genuinely reading different evidence even though either alone suffices on clean video.</a:t>
             </a:r>
           </a:p>
           <a:p>
@@ -9930,7 +10980,7 @@
                 </a:solidFill>
                 <a:latin typeface="Segoe UI"/>
               </a:rPr>
-              <a:t>•  On clean video the branches are redundant, so fusion adds confidence rather than coverage.</a:t>
+              <a:t>•  Facial Component Guidance mostly works: 3 of 4 queries sit on their own anatomy, but the nose query drifts onto skin once the face is swapped.</a:t>
             </a:r>
           </a:p>
           <a:p>
@@ -9981,7 +11031,7 @@
 </p:sld>
 </file>
 
-<file path=ppt/slides/slide14.xml><?xml version="1.0" encoding="utf-8"?>
+<file path=ppt/slides/slide16.xml><?xml version="1.0" encoding="utf-8"?>
 <p:sld xmlns:a="http://schemas.openxmlformats.org/drawingml/2006/main" xmlns:p="http://schemas.openxmlformats.org/presentationml/2006/main" xmlns:r="http://schemas.openxmlformats.org/officeDocument/2006/relationships">
   <p:cSld>
     <p:bg>
@@ -10151,14 +11201,14 @@
           <a:p>
             <a:pPr algn="l">
               <a:lnSpc>
-                <a:spcPct val="127000"/>
+                <a:spcPct val="124000"/>
               </a:lnSpc>
               <a:spcAft>
                 <a:spcPts val="500"/>
               </a:spcAft>
             </a:pPr>
             <a:r>
-              <a:rPr sz="1150" b="0" i="0">
+              <a:rPr sz="1100" b="0" i="0">
                 <a:solidFill>
                   <a:srgbClr val="1C1C24"/>
                 </a:solidFill>
@@ -10170,14 +11220,14 @@
           <a:p>
             <a:pPr algn="l">
               <a:lnSpc>
-                <a:spcPct val="127000"/>
+                <a:spcPct val="124000"/>
               </a:lnSpc>
               <a:spcAft>
                 <a:spcPts val="500"/>
               </a:spcAft>
             </a:pPr>
             <a:r>
-              <a:rPr sz="1150" b="0" i="0">
+              <a:rPr sz="1100" b="0" i="0">
                 <a:solidFill>
                   <a:srgbClr val="1C1C24"/>
                 </a:solidFill>
@@ -10189,14 +11239,14 @@
           <a:p>
             <a:pPr algn="l">
               <a:lnSpc>
-                <a:spcPct val="127000"/>
+                <a:spcPct val="124000"/>
               </a:lnSpc>
               <a:spcAft>
                 <a:spcPts val="500"/>
               </a:spcAft>
             </a:pPr>
             <a:r>
-              <a:rPr sz="1150" b="0" i="0">
+              <a:rPr sz="1100" b="0" i="0">
                 <a:solidFill>
                   <a:srgbClr val="1C1C24"/>
                 </a:solidFill>
@@ -10208,58 +11258,96 @@
           <a:p>
             <a:pPr algn="l">
               <a:lnSpc>
-                <a:spcPct val="127000"/>
+                <a:spcPct val="124000"/>
               </a:lnSpc>
               <a:spcAft>
                 <a:spcPts val="500"/>
               </a:spcAft>
             </a:pPr>
             <a:r>
-              <a:rPr sz="1150" b="0" i="0">
+              <a:rPr sz="1100" b="0" i="0">
                 <a:solidFill>
                   <a:srgbClr val="1C1C24"/>
                 </a:solidFill>
                 <a:latin typeface="Segoe UI"/>
               </a:rPr>
-              <a:t>•  Shapley efficiency holds exactly: φ_S + φ_T = P_final − 0.5.</a:t>
+              <a:t>•  The region decomposition reproduces the spatial head logit to 4e-16.</a:t>
             </a:r>
           </a:p>
           <a:p>
             <a:pPr algn="l">
               <a:lnSpc>
-                <a:spcPct val="127000"/>
+                <a:spcPct val="124000"/>
               </a:lnSpc>
               <a:spcAft>
                 <a:spcPts val="500"/>
               </a:spcAft>
             </a:pPr>
             <a:r>
-              <a:rPr sz="1150" b="0" i="0">
+              <a:rPr sz="1100" b="0" i="0">
                 <a:solidFill>
                   <a:srgbClr val="1C1C24"/>
                 </a:solidFill>
                 <a:latin typeface="Segoe UI"/>
               </a:rPr>
-              <a:t>•  All 569 checkpoint tensors load with 0 missing and 0 unexpected keys; every trainable weight comes from the released file.</a:t>
+              <a:t>•  TWO INDEPENDENT decompositions (by model query, and by landmark-defined patch region) agree that the eyes dominate the fake verdict.</a:t>
             </a:r>
           </a:p>
           <a:p>
             <a:pPr algn="l">
               <a:lnSpc>
-                <a:spcPct val="127000"/>
+                <a:spcPct val="124000"/>
               </a:lnSpc>
               <a:spcAft>
                 <a:spcPts val="500"/>
               </a:spcAft>
             </a:pPr>
             <a:r>
-              <a:rPr sz="1150" b="0" i="0">
+              <a:rPr sz="1100" b="0" i="0">
                 <a:solidFill>
                   <a:srgbClr val="1C1C24"/>
                 </a:solidFill>
                 <a:latin typeface="Segoe UI"/>
               </a:rPr>
-              <a:t>•  Labels verified from FaceForensics++ naming and confirmed visually: the difference between the pair is confined to the inner face, 22.7× the background difference.</a:t>
+              <a:t>•  Shapley efficiency holds exactly: φ_S + φ_T = P_final − 0.5.</a:t>
+            </a:r>
+          </a:p>
+          <a:p>
+            <a:pPr algn="l">
+              <a:lnSpc>
+                <a:spcPct val="124000"/>
+              </a:lnSpc>
+              <a:spcAft>
+                <a:spcPts val="500"/>
+              </a:spcAft>
+            </a:pPr>
+            <a:r>
+              <a:rPr sz="1100" b="0" i="0">
+                <a:solidFill>
+                  <a:srgbClr val="1C1C24"/>
+                </a:solidFill>
+                <a:latin typeface="Segoe UI"/>
+              </a:rPr>
+              <a:t>•  All 569 checkpoint tensors load with 0 missing and 0 unexpected keys.</a:t>
+            </a:r>
+          </a:p>
+          <a:p>
+            <a:pPr algn="l">
+              <a:lnSpc>
+                <a:spcPct val="124000"/>
+              </a:lnSpc>
+              <a:spcAft>
+                <a:spcPts val="500"/>
+              </a:spcAft>
+            </a:pPr>
+            <a:r>
+              <a:rPr sz="1100" b="0" i="0">
+                <a:solidFill>
+                  <a:srgbClr val="1C1C24"/>
+                </a:solidFill>
+                <a:latin typeface="Segoe UI"/>
+              </a:rPr>
+              <a:t>•  Labels verified from FaceForensics++ naming and visually: the difference between the pair is confined to the inner face, 22.7× the background difference.</a:t>
             </a:r>
           </a:p>
         </p:txBody>
@@ -10288,14 +11376,14 @@
           <a:p>
             <a:pPr algn="l">
               <a:lnSpc>
-                <a:spcPct val="127000"/>
+                <a:spcPct val="124000"/>
               </a:lnSpc>
               <a:spcAft>
                 <a:spcPts val="500"/>
               </a:spcAft>
             </a:pPr>
             <a:r>
-              <a:rPr sz="1150" b="0" i="0">
+              <a:rPr sz="1100" b="0" i="0">
                 <a:solidFill>
                   <a:srgbClr val="1C1C24"/>
                 </a:solidFill>
@@ -10307,14 +11395,14 @@
           <a:p>
             <a:pPr algn="l">
               <a:lnSpc>
-                <a:spcPct val="127000"/>
+                <a:spcPct val="124000"/>
               </a:lnSpc>
               <a:spcAft>
                 <a:spcPts val="500"/>
               </a:spcAft>
             </a:pPr>
             <a:r>
-              <a:rPr sz="1150" b="0" i="0">
+              <a:rPr sz="1100" b="0" i="0">
                 <a:solidFill>
                   <a:srgbClr val="1C1C24"/>
                 </a:solidFill>
@@ -10326,58 +11414,58 @@
           <a:p>
             <a:pPr algn="l">
               <a:lnSpc>
-                <a:spcPct val="127000"/>
+                <a:spcPct val="124000"/>
               </a:lnSpc>
               <a:spcAft>
                 <a:spcPts val="500"/>
               </a:spcAft>
             </a:pPr>
             <a:r>
-              <a:rPr sz="1150" b="0" i="0">
+              <a:rPr sz="1100" b="0" i="0">
                 <a:solidFill>
                   <a:srgbClr val="1C1C24"/>
                 </a:solidFill>
                 <a:latin typeface="Segoe UI"/>
               </a:rPr>
-              <a:t>•  Single-branch numbers are inference-time ablations of this checkpoint, not models re-trained with op_mode=[S] or [T], which would converge to different weights.</a:t>
+              <a:t>•  Region boundaries come from nearest-landmark assignment on a 16×16 grid, so a patch straddling two regions is assigned to one. The per-patch contributions are exact; the grouping into regions is the approximate step.</a:t>
             </a:r>
           </a:p>
           <a:p>
             <a:pPr algn="l">
               <a:lnSpc>
-                <a:spcPct val="127000"/>
+                <a:spcPct val="124000"/>
               </a:lnSpc>
               <a:spcAft>
                 <a:spcPts val="500"/>
               </a:spcAft>
             </a:pPr>
             <a:r>
-              <a:rPr sz="1150" b="0" i="0">
+              <a:rPr sz="1100" b="0" i="0">
                 <a:solidFill>
                   <a:srgbClr val="1C1C24"/>
                 </a:solidFill>
                 <a:latin typeface="Segoe UI"/>
               </a:rPr>
-              <a:t>•  Patch-to-zone mapping uses nearest-landmark assignment on a 16×16 grid, so zone boundaries are approximate even though patch contributions are exact.</a:t>
+              <a:t>•  Single-branch numbers are inference-time ablations of this checkpoint, not models re-trained with op_mode=[S] or [T], which would converge to different weights.</a:t>
             </a:r>
           </a:p>
           <a:p>
             <a:pPr algn="l">
               <a:lnSpc>
-                <a:spcPct val="127000"/>
+                <a:spcPct val="124000"/>
               </a:lnSpc>
               <a:spcAft>
                 <a:spcPts val="500"/>
               </a:spcAft>
             </a:pPr>
             <a:r>
-              <a:rPr sz="1150" b="0" i="0">
+              <a:rPr sz="1100" b="0" i="0">
                 <a:solidFill>
                   <a:srgbClr val="1C1C24"/>
                 </a:solidFill>
                 <a:latin typeface="Segoe UI"/>
               </a:rPr>
-              <a:t>•  The robustness sweep uses 8 clips per condition; the main analysis uses 60.</a:t>
+              <a:t>•  The robustness sweep uses 8 clips per condition; the main analysis 60, the region analysis 30.</a:t>
             </a:r>
           </a:p>
         </p:txBody>
@@ -10390,7 +11478,7 @@
 </p:sld>
 </file>
 
-<file path=ppt/slides/slide15.xml><?xml version="1.0" encoding="utf-8"?>
+<file path=ppt/slides/slide17.xml><?xml version="1.0" encoding="utf-8"?>
 <p:sld xmlns:a="http://schemas.openxmlformats.org/drawingml/2006/main" xmlns:p="http://schemas.openxmlformats.org/presentationml/2006/main" xmlns:r="http://schemas.openxmlformats.org/officeDocument/2006/relationships">
   <p:cSld>
     <p:bg>
@@ -10560,14 +11648,14 @@
           <a:p>
             <a:pPr algn="l">
               <a:lnSpc>
-                <a:spcPct val="130000"/>
+                <a:spcPct val="128000"/>
               </a:lnSpc>
               <a:spcAft>
                 <a:spcPts val="500"/>
               </a:spcAft>
             </a:pPr>
             <a:r>
-              <a:rPr sz="1200" b="0" i="0">
+              <a:rPr sz="1150" b="0" i="0">
                 <a:solidFill>
                   <a:srgbClr val="1C1C24"/>
                 </a:solidFill>
@@ -10579,14 +11667,14 @@
           <a:p>
             <a:pPr algn="l">
               <a:lnSpc>
-                <a:spcPct val="130000"/>
+                <a:spcPct val="128000"/>
               </a:lnSpc>
               <a:spcAft>
                 <a:spcPts val="500"/>
               </a:spcAft>
             </a:pPr>
             <a:r>
-              <a:rPr sz="1200" b="0" i="0">
+              <a:rPr sz="1150" b="0" i="0">
                 <a:solidFill>
                   <a:srgbClr val="1C1C24"/>
                 </a:solidFill>
@@ -10598,14 +11686,14 @@
           <a:p>
             <a:pPr algn="l">
               <a:lnSpc>
-                <a:spcPct val="130000"/>
+                <a:spcPct val="128000"/>
               </a:lnSpc>
               <a:spcAft>
                 <a:spcPts val="500"/>
               </a:spcAft>
             </a:pPr>
             <a:r>
-              <a:rPr sz="1200" b="0" i="0">
+              <a:rPr sz="1150" b="0" i="0">
                 <a:solidFill>
                   <a:srgbClr val="1C1C24"/>
                 </a:solidFill>
@@ -10617,14 +11705,14 @@
           <a:p>
             <a:pPr algn="l">
               <a:lnSpc>
-                <a:spcPct val="130000"/>
+                <a:spcPct val="128000"/>
               </a:lnSpc>
               <a:spcAft>
                 <a:spcPts val="500"/>
               </a:spcAft>
             </a:pPr>
             <a:r>
-              <a:rPr sz="1200" b="0" i="0">
+              <a:rPr sz="1150" b="0" i="0">
                 <a:solidFill>
                   <a:srgbClr val="1C1C24"/>
                 </a:solidFill>
@@ -10636,14 +11724,14 @@
           <a:p>
             <a:pPr algn="l">
               <a:lnSpc>
-                <a:spcPct val="130000"/>
+                <a:spcPct val="128000"/>
               </a:lnSpc>
               <a:spcAft>
                 <a:spcPts val="500"/>
               </a:spcAft>
             </a:pPr>
             <a:r>
-              <a:rPr sz="1200" b="0" i="0">
+              <a:rPr sz="1150" b="0" i="0">
                 <a:solidFill>
                   <a:srgbClr val="1C1C24"/>
                 </a:solidFill>
@@ -10655,14 +11743,14 @@
           <a:p>
             <a:pPr algn="l">
               <a:lnSpc>
-                <a:spcPct val="130000"/>
+                <a:spcPct val="128000"/>
               </a:lnSpc>
               <a:spcAft>
                 <a:spcPts val="500"/>
               </a:spcAft>
             </a:pPr>
             <a:r>
-              <a:rPr sz="1200" b="0" i="0">
+              <a:rPr sz="1150" b="0" i="0">
                 <a:solidFill>
                   <a:srgbClr val="1C1C24"/>
                 </a:solidFill>
@@ -10674,128 +11762,166 @@
           <a:p>
             <a:pPr algn="l">
               <a:lnSpc>
-                <a:spcPct val="130000"/>
+                <a:spcPct val="128000"/>
               </a:lnSpc>
               <a:spcAft>
                 <a:spcPts val="500"/>
               </a:spcAft>
             </a:pPr>
             <a:r>
-              <a:rPr sz="1200" b="0" i="0">
+              <a:rPr sz="1150" b="0" i="0">
                 <a:solidFill>
                   <a:srgbClr val="1C1C24"/>
                 </a:solidFill>
                 <a:latin typeface="Segoe UI"/>
               </a:rPr>
-              <a:t>6.  robustness sweep              python xai/run_robustness.py --levels 1 3 5</a:t>
+              <a:t>6.  REGION analysis (by patches)  python xai/run_region_analysis.py --max-clips 30</a:t>
             </a:r>
           </a:p>
           <a:p>
             <a:pPr algn="l">
               <a:lnSpc>
-                <a:spcPct val="130000"/>
+                <a:spcPct val="128000"/>
               </a:lnSpc>
               <a:spcAft>
                 <a:spcPts val="500"/>
               </a:spcAft>
             </a:pPr>
             <a:r>
-              <a:rPr sz="1200" b="0" i="0">
+              <a:rPr sz="1150" b="0" i="0">
                 <a:solidFill>
                   <a:srgbClr val="1C1C24"/>
                 </a:solidFill>
                 <a:latin typeface="Segoe UI"/>
               </a:rPr>
-              <a:t>7.  audits                        python xai/audit/audit_math2.py , audit_pipeline.py</a:t>
+              <a:t>7.  region figures                python xai/make_region_figures.py</a:t>
             </a:r>
           </a:p>
           <a:p>
             <a:pPr algn="l">
               <a:lnSpc>
-                <a:spcPct val="130000"/>
+                <a:spcPct val="128000"/>
               </a:lnSpc>
               <a:spcAft>
                 <a:spcPts val="500"/>
               </a:spcAft>
             </a:pPr>
             <a:r>
-              <a:rPr sz="1200" b="0" i="0">
+              <a:rPr sz="1150" b="0" i="0">
                 <a:solidFill>
                   <a:srgbClr val="1C1C24"/>
                 </a:solidFill>
                 <a:latin typeface="Segoe UI"/>
               </a:rPr>
-              <a:t>8.  deck                          python xai/build_deck.py</a:t>
+              <a:t>8.  robustness sweep              python xai/run_robustness.py --levels 1 3 5</a:t>
             </a:r>
           </a:p>
           <a:p>
             <a:pPr algn="l">
               <a:lnSpc>
-                <a:spcPct val="130000"/>
+                <a:spcPct val="128000"/>
               </a:lnSpc>
               <a:spcAft>
                 <a:spcPts val="500"/>
               </a:spcAft>
             </a:pPr>
             <a:r>
-              <a:rPr sz="1200" b="0" i="0">
+              <a:rPr sz="1150" b="0" i="0">
                 <a:solidFill>
                   <a:srgbClr val="1C1C24"/>
                 </a:solidFill>
                 <a:latin typeface="Segoe UI"/>
               </a:rPr>
-              <a:t/>
+              <a:t>9.  audits                        python xai/audit/audit_math2.py , audit_pipeline.py</a:t>
             </a:r>
           </a:p>
           <a:p>
             <a:pPr algn="l">
               <a:lnSpc>
-                <a:spcPct val="130000"/>
+                <a:spcPct val="128000"/>
               </a:lnSpc>
               <a:spcAft>
                 <a:spcPts val="500"/>
               </a:spcAft>
             </a:pPr>
             <a:r>
-              <a:rPr sz="1200" b="0" i="0">
+              <a:rPr sz="1150" b="0" i="0">
                 <a:solidFill>
                   <a:srgbClr val="1C1C24"/>
                 </a:solidFill>
                 <a:latin typeface="Segoe UI"/>
               </a:rPr>
-              <a:t>Environment: Windows, RTX 3050 Ti 4 GB (peak 2.5 GB at batch size 2), torch 2.6 + CUDA 12.4.</a:t>
+              <a:t>10. deck                          python xai/build_deck.py</a:t>
             </a:r>
           </a:p>
           <a:p>
             <a:pPr algn="l">
               <a:lnSpc>
-                <a:spcPct val="130000"/>
+                <a:spcPct val="128000"/>
               </a:lnSpc>
               <a:spcAft>
                 <a:spcPts val="500"/>
               </a:spcAft>
             </a:pPr>
             <a:r>
-              <a:rPr sz="1200" b="0" i="0">
+              <a:rPr sz="1150" b="0" i="0">
                 <a:solidFill>
                   <a:srgbClr val="1C1C24"/>
                 </a:solidFill>
                 <a:latin typeface="Segoe UI"/>
               </a:rPr>
-              <a:t>Outputs: xai/out/{report,derived,robustness}.json + arrays.npz; figures in xai/figs/.</a:t>
+              <a:t/>
             </a:r>
           </a:p>
           <a:p>
             <a:pPr algn="l">
               <a:lnSpc>
-                <a:spcPct val="130000"/>
+                <a:spcPct val="128000"/>
               </a:lnSpc>
               <a:spcAft>
                 <a:spcPts val="500"/>
               </a:spcAft>
             </a:pPr>
             <a:r>
-              <a:rPr sz="1200" b="0" i="0">
+              <a:rPr sz="1150" b="0" i="0">
+                <a:solidFill>
+                  <a:srgbClr val="1C1C24"/>
+                </a:solidFill>
+                <a:latin typeface="Segoe UI"/>
+              </a:rPr>
+              <a:t>Environment: Windows, RTX 3050 Ti 4 GB (peak 2.5 GB at batch size 2), torch 2.6 + CUDA 12.4.</a:t>
+            </a:r>
+          </a:p>
+          <a:p>
+            <a:pPr algn="l">
+              <a:lnSpc>
+                <a:spcPct val="128000"/>
+              </a:lnSpc>
+              <a:spcAft>
+                <a:spcPts val="500"/>
+              </a:spcAft>
+            </a:pPr>
+            <a:r>
+              <a:rPr sz="1150" b="0" i="0">
+                <a:solidFill>
+                  <a:srgbClr val="1C1C24"/>
+                </a:solidFill>
+                <a:latin typeface="Segoe UI"/>
+              </a:rPr>
+              <a:t>Outputs: xai/out/{report,derived,regions,robustness}.json + arrays.npz, regions.npz.</a:t>
+            </a:r>
+          </a:p>
+          <a:p>
+            <a:pPr algn="l">
+              <a:lnSpc>
+                <a:spcPct val="128000"/>
+              </a:lnSpc>
+              <a:spcAft>
+                <a:spcPts val="500"/>
+              </a:spcAft>
+            </a:pPr>
+            <a:r>
+              <a:rPr sz="1150" b="0" i="0">
                 <a:solidFill>
                   <a:srgbClr val="1C1C24"/>
                 </a:solidFill>
@@ -14035,7 +15161,7 @@
                 </a:solidFill>
                 <a:latin typeface="Segoe UI"/>
               </a:rPr>
-              <a:t>RESULT 3</a:t>
+              <a:t>RESULT 3A</a:t>
             </a:r>
           </a:p>
         </p:txBody>
@@ -14077,7 +15203,7 @@
                 </a:solidFill>
                 <a:latin typeface="Segoe UI"/>
               </a:rPr>
-              <a:t>Why it said YES (fake)</a:t>
+              <a:t>Why it said YES — view 1: the model's own components</a:t>
             </a:r>
           </a:p>
         </p:txBody>
@@ -14119,7 +15245,7 @@
                 </a:solidFill>
                 <a:latin typeface="Segoe UI"/>
               </a:rPr>
-              <a:t>The spatial branch broken into its four guided facial components</a:t>
+              <a:t>Decomposing the spatial branch over its four guided queries (feature space)</a:t>
             </a:r>
           </a:p>
         </p:txBody>
@@ -14158,7 +15284,7 @@
         </p:nvGraphicFramePr>
         <p:xfrm>
           <a:off x="566928" y="4617720"/>
-          <a:ext cx="11057836" cy="1257300"/>
+          <a:ext cx="11057837" cy="1257300"/>
         </p:xfrm>
         <a:graphic>
           <a:graphicData uri="http://schemas.openxmlformats.org/drawingml/2006/table">
@@ -14167,10 +15293,10 @@
                 <a:tableStyleId>{5C22544A-7EE6-4342-B048-85BDC9FD1C3A}</a:tableStyleId>
               </a:tblPr>
               <a:tblGrid>
-                <a:gridCol w="1898820"/>
-                <a:gridCol w="2233906"/>
+                <a:gridCol w="2122211"/>
+                <a:gridCol w="2122211"/>
                 <a:gridCol w="1340344"/>
-                <a:gridCol w="2233906"/>
+                <a:gridCol w="2122211"/>
                 <a:gridCol w="1340344"/>
                 <a:gridCol w="2010516"/>
               </a:tblGrid>
@@ -14188,7 +15314,7 @@
                           </a:solidFill>
                           <a:latin typeface="Segoe UI"/>
                         </a:rPr>
-                        <a:t>component</a:t>
+                        <a:t>component query</a:t>
                       </a:r>
                     </a:p>
                   </a:txBody>
@@ -14915,7 +16041,7 @@
                 </a:solidFill>
                 <a:latin typeface="Segoe UI"/>
               </a:rPr>
-              <a:t>•  MAIN CAUSE of the FAKE verdict: the EYES — 45.6% of the spatial evidence, then skin 27.1%.</a:t>
+              <a:t>•  MAIN CAUSE of the FAKE verdict: the EYES query — 45.6% of the spatial evidence, then skin 27.1%.</a:t>
             </a:r>
           </a:p>
           <a:p>
@@ -14934,7 +16060,7 @@
                 </a:solidFill>
                 <a:latin typeface="Segoe UI"/>
               </a:rPr>
-              <a:t>•  In the real video the nose votes REAL (-0.601); after the swap every component turns towards FAKE, the nose shifting most (+1.039).</a:t>
+              <a:t>•  Caveat: a query is a learned embedding that attends over ALL 256 patches, so this is a FEATURE-space split, not a face-region split. Next slide does it by region.</a:t>
             </a:r>
           </a:p>
         </p:txBody>
@@ -15046,7 +16172,7 @@
                 </a:solidFill>
                 <a:latin typeface="Segoe UI"/>
               </a:rPr>
-              <a:t>RESULT 4</a:t>
+              <a:t>RESULT 3B</a:t>
             </a:r>
           </a:p>
         </p:txBody>
@@ -15088,7 +16214,7 @@
                 </a:solidFill>
                 <a:latin typeface="Segoe UI"/>
               </a:rPr>
-              <a:t>Where in the face the temporal evidence lies</a:t>
+              <a:t>Why it said YES — view 2: patches grouped by face region</a:t>
             </a:r>
           </a:p>
         </p:txBody>
@@ -15130,14 +16256,14 @@
                 </a:solidFill>
                 <a:latin typeface="Segoe UI"/>
               </a:rPr>
-              <a:t>The temporal branch output is a 16×16 grid, so it maps straight back onto the face</a:t>
+              <a:t>Cut the 16×16 patch grid into landmark-defined regions, then attribute each region</a:t>
             </a:r>
           </a:p>
         </p:txBody>
       </p:sp>
       <p:pic>
         <p:nvPicPr>
-          <p:cNvPr id="6" name="Picture 5" descr="f5_temporal_maps.png"/>
+          <p:cNvPr id="6" name="Picture 5" descr="f11_regions.png"/>
           <p:cNvPicPr>
             <a:picLocks noChangeAspect="1"/>
           </p:cNvPicPr>
@@ -15151,124 +16277,25 @@
         </p:blipFill>
         <p:spPr>
           <a:xfrm>
-            <a:off x="1457278" y="1554480"/>
-            <a:ext cx="9277138" cy="3017520"/>
+            <a:off x="809613" y="1554480"/>
+            <a:ext cx="10572467" cy="2880360"/>
           </a:xfrm>
           <a:prstGeom prst="rect">
             <a:avLst/>
           </a:prstGeom>
         </p:spPr>
       </p:pic>
-      <p:sp>
-        <p:nvSpPr>
-          <p:cNvPr id="7" name="TextBox 6"/>
-          <p:cNvSpPr txBox="1"/>
-          <p:nvPr/>
-        </p:nvSpPr>
-        <p:spPr>
-          <a:xfrm>
-            <a:off x="566928" y="4700016"/>
-            <a:ext cx="5349240" cy="1737360"/>
-          </a:xfrm>
-          <a:prstGeom prst="rect">
-            <a:avLst/>
-          </a:prstGeom>
-          <a:noFill/>
-        </p:spPr>
-        <p:txBody>
-          <a:bodyPr wrap="square" lIns="0" rIns="0" tIns="0" bIns="0">
-            <a:spAutoFit/>
-          </a:bodyPr>
-          <a:lstStyle/>
-          <a:p>
-            <a:pPr algn="l">
-              <a:lnSpc>
-                <a:spcPct val="124000"/>
-              </a:lnSpc>
-              <a:spcAft>
-                <a:spcPts val="500"/>
-              </a:spcAft>
-            </a:pPr>
-            <a:r>
-              <a:rPr sz="1150" b="0" i="0">
-                <a:solidFill>
-                  <a:srgbClr val="1C1C24"/>
-                </a:solidFill>
-                <a:latin typeface="Segoe UI"/>
-              </a:rPr>
-              <a:t>Reading the maps:</a:t>
-            </a:r>
-          </a:p>
-          <a:p>
-            <a:pPr algn="l">
-              <a:lnSpc>
-                <a:spcPct val="124000"/>
-              </a:lnSpc>
-              <a:spcAft>
-                <a:spcPts val="500"/>
-              </a:spcAft>
-            </a:pPr>
-            <a:r>
-              <a:rPr sz="1150" b="0" i="0">
-                <a:solidFill>
-                  <a:srgbClr val="1C1C24"/>
-                </a:solidFill>
-                <a:latin typeface="Segoe UI"/>
-              </a:rPr>
-              <a:t>•  red = this patch pushed towards FAKE, blue = towards REAL;</a:t>
-            </a:r>
-          </a:p>
-          <a:p>
-            <a:pPr algn="l">
-              <a:lnSpc>
-                <a:spcPct val="124000"/>
-              </a:lnSpc>
-              <a:spcAft>
-                <a:spcPts val="500"/>
-              </a:spcAft>
-            </a:pPr>
-            <a:r>
-              <a:rPr sz="1150" b="0" i="0">
-                <a:solidFill>
-                  <a:srgbClr val="1C1C24"/>
-                </a:solidFill>
-                <a:latin typeface="Segoe UI"/>
-              </a:rPr>
-              <a:t>•  green dots are the averaged 68 facial landmarks;</a:t>
-            </a:r>
-          </a:p>
-          <a:p>
-            <a:pPr algn="l">
-              <a:lnSpc>
-                <a:spcPct val="124000"/>
-              </a:lnSpc>
-              <a:spcAft>
-                <a:spcPts val="500"/>
-              </a:spcAft>
-            </a:pPr>
-            <a:r>
-              <a:rPr sz="1150" b="0" i="0">
-                <a:solidFill>
-                  <a:srgbClr val="1C1C24"/>
-                </a:solidFill>
-                <a:latin typeface="Segoe UI"/>
-              </a:rPr>
-              <a:t>•  the right panel is FAKE minus REAL — exactly where the swap created new evidence.</a:t>
-            </a:r>
-          </a:p>
-        </p:txBody>
-      </p:sp>
       <p:graphicFrame>
         <p:nvGraphicFramePr>
-          <p:cNvPr id="8" name="Table 7"/>
+          <p:cNvPr id="7" name="Table 6"/>
           <p:cNvGraphicFramePr>
             <a:graphicFrameLocks noGrp="1"/>
           </p:cNvGraphicFramePr>
           <p:nvPr/>
         </p:nvGraphicFramePr>
         <p:xfrm>
-          <a:off x="6172200" y="4700016"/>
-          <a:ext cx="5449822" cy="1234440"/>
+          <a:off x="566928" y="4526279"/>
+          <a:ext cx="11057836" cy="1257300"/>
         </p:xfrm>
         <a:graphic>
           <a:graphicData uri="http://schemas.openxmlformats.org/drawingml/2006/table">
@@ -15277,12 +16304,14 @@
                 <a:tableStyleId>{5C22544A-7EE6-4342-B048-85BDC9FD1C3A}</a:tableStyleId>
               </a:tblPr>
               <a:tblGrid>
-                <a:gridCol w="2199051"/>
-                <a:gridCol w="1051720"/>
-                <a:gridCol w="1051720"/>
-                <a:gridCol w="1147331"/>
+                <a:gridCol w="1944235"/>
+                <a:gridCol w="1336661"/>
+                <a:gridCol w="1822720"/>
+                <a:gridCol w="2065750"/>
+                <a:gridCol w="1822720"/>
+                <a:gridCol w="2065750"/>
               </a:tblGrid>
-              <a:tr h="246888">
+              <a:tr h="251460">
                 <a:tc>
                   <a:txBody>
                     <a:bodyPr/>
@@ -15296,7 +16325,7 @@
                           </a:solidFill>
                           <a:latin typeface="Segoe UI"/>
                         </a:rPr>
-                        <a:t>zone (area-normalised)</a:t>
+                        <a:t>face region</a:t>
                       </a:r>
                     </a:p>
                   </a:txBody>
@@ -15319,7 +16348,7 @@
                           </a:solidFill>
                           <a:latin typeface="Segoe UI"/>
                         </a:rPr>
-                        <a:t>REAL</a:t>
+                        <a:t>patches</a:t>
                       </a:r>
                     </a:p>
                   </a:txBody>
@@ -15342,7 +16371,7 @@
                           </a:solidFill>
                           <a:latin typeface="Segoe UI"/>
                         </a:rPr>
-                        <a:t>FAKE</a:t>
+                        <a:t>FAKE share</a:t>
                       </a:r>
                     </a:p>
                   </a:txBody>
@@ -15365,7 +16394,7 @@
                           </a:solidFill>
                           <a:latin typeface="Segoe UI"/>
                         </a:rPr>
-                        <a:t>change</a:t>
+                        <a:t>FAKE signed</a:t>
                       </a:r>
                     </a:p>
                   </a:txBody>
@@ -15375,8 +16404,54 @@
                     </a:solidFill>
                   </a:tcPr>
                 </a:tc>
+                <a:tc>
+                  <a:txBody>
+                    <a:bodyPr/>
+                    <a:lstStyle/>
+                    <a:p>
+                      <a:pPr algn="ctr"/>
+                      <a:r>
+                        <a:rPr sz="1100" b="1">
+                          <a:solidFill>
+                            <a:srgbClr val="FFFFFF"/>
+                          </a:solidFill>
+                          <a:latin typeface="Segoe UI"/>
+                        </a:rPr>
+                        <a:t>REAL share</a:t>
+                      </a:r>
+                    </a:p>
+                  </a:txBody>
+                  <a:tcPr marL="54864" marR="54864" marT="9144" marB="9144">
+                    <a:solidFill>
+                      <a:srgbClr val="2E6FD9"/>
+                    </a:solidFill>
+                  </a:tcPr>
+                </a:tc>
+                <a:tc>
+                  <a:txBody>
+                    <a:bodyPr/>
+                    <a:lstStyle/>
+                    <a:p>
+                      <a:pPr algn="ctr"/>
+                      <a:r>
+                        <a:rPr sz="1100" b="1">
+                          <a:solidFill>
+                            <a:srgbClr val="FFFFFF"/>
+                          </a:solidFill>
+                          <a:latin typeface="Segoe UI"/>
+                        </a:rPr>
+                        <a:t>REAL signed</a:t>
+                      </a:r>
+                    </a:p>
+                  </a:txBody>
+                  <a:tcPr marL="54864" marR="54864" marT="9144" marB="9144">
+                    <a:solidFill>
+                      <a:srgbClr val="2E6FD9"/>
+                    </a:solidFill>
+                  </a:tcPr>
+                </a:tc>
               </a:tr>
-              <a:tr h="246888">
+              <a:tr h="251460">
                 <a:tc>
                   <a:txBody>
                     <a:bodyPr/>
@@ -15413,7 +16488,7 @@
                           </a:solidFill>
                           <a:latin typeface="Segoe UI"/>
                         </a:rPr>
-                        <a:t>0.0150</a:t>
+                        <a:t>46</a:t>
                       </a:r>
                     </a:p>
                   </a:txBody>
@@ -15436,7 +16511,7 @@
                           </a:solidFill>
                           <a:latin typeface="Segoe UI"/>
                         </a:rPr>
-                        <a:t>0.0399</a:t>
+                        <a:t>47.7%</a:t>
                       </a:r>
                     </a:p>
                   </a:txBody>
@@ -15459,7 +16534,7 @@
                           </a:solidFill>
                           <a:latin typeface="Segoe UI"/>
                         </a:rPr>
-                        <a:t>+0.0250</a:t>
+                        <a:t>+1.1507</a:t>
                       </a:r>
                     </a:p>
                   </a:txBody>
@@ -15469,8 +16544,54 @@
                     </a:solidFill>
                   </a:tcPr>
                 </a:tc>
+                <a:tc>
+                  <a:txBody>
+                    <a:bodyPr/>
+                    <a:lstStyle/>
+                    <a:p>
+                      <a:pPr algn="ctr"/>
+                      <a:r>
+                        <a:rPr sz="1100" b="0">
+                          <a:solidFill>
+                            <a:srgbClr val="1C1C24"/>
+                          </a:solidFill>
+                          <a:latin typeface="Segoe UI"/>
+                        </a:rPr>
+                        <a:t>37.7%</a:t>
+                      </a:r>
+                    </a:p>
+                  </a:txBody>
+                  <a:tcPr marL="54864" marR="54864" marT="9144" marB="9144">
+                    <a:solidFill>
+                      <a:srgbClr val="F2F4F8"/>
+                    </a:solidFill>
+                  </a:tcPr>
+                </a:tc>
+                <a:tc>
+                  <a:txBody>
+                    <a:bodyPr/>
+                    <a:lstStyle/>
+                    <a:p>
+                      <a:pPr algn="ctr"/>
+                      <a:r>
+                        <a:rPr sz="1100" b="0">
+                          <a:solidFill>
+                            <a:srgbClr val="1C1C24"/>
+                          </a:solidFill>
+                          <a:latin typeface="Segoe UI"/>
+                        </a:rPr>
+                        <a:t>+0.4331</a:t>
+                      </a:r>
+                    </a:p>
+                  </a:txBody>
+                  <a:tcPr marL="54864" marR="54864" marT="9144" marB="9144">
+                    <a:solidFill>
+                      <a:srgbClr val="F2F4F8"/>
+                    </a:solidFill>
+                  </a:tcPr>
+                </a:tc>
               </a:tr>
-              <a:tr h="246888">
+              <a:tr h="251460">
                 <a:tc>
                   <a:txBody>
                     <a:bodyPr/>
@@ -15507,7 +16628,7 @@
                           </a:solidFill>
                           <a:latin typeface="Segoe UI"/>
                         </a:rPr>
-                        <a:t>0.0342</a:t>
+                        <a:t>18</a:t>
                       </a:r>
                     </a:p>
                   </a:txBody>
@@ -15530,7 +16651,7 @@
                           </a:solidFill>
                           <a:latin typeface="Segoe UI"/>
                         </a:rPr>
-                        <a:t>0.0539</a:t>
+                        <a:t>5.6%</a:t>
                       </a:r>
                     </a:p>
                   </a:txBody>
@@ -15553,7 +16674,7 @@
                           </a:solidFill>
                           <a:latin typeface="Segoe UI"/>
                         </a:rPr>
-                        <a:t>+0.0197</a:t>
+                        <a:t>-0.1347</a:t>
                       </a:r>
                     </a:p>
                   </a:txBody>
@@ -15563,8 +16684,54 @@
                     </a:solidFill>
                   </a:tcPr>
                 </a:tc>
+                <a:tc>
+                  <a:txBody>
+                    <a:bodyPr/>
+                    <a:lstStyle/>
+                    <a:p>
+                      <a:pPr algn="ctr"/>
+                      <a:r>
+                        <a:rPr sz="1100" b="0">
+                          <a:solidFill>
+                            <a:srgbClr val="1C1C24"/>
+                          </a:solidFill>
+                          <a:latin typeface="Segoe UI"/>
+                        </a:rPr>
+                        <a:t>55.7%</a:t>
+                      </a:r>
+                    </a:p>
+                  </a:txBody>
+                  <a:tcPr marL="54864" marR="54864" marT="9144" marB="9144">
+                    <a:solidFill>
+                      <a:srgbClr val="FFFFFF"/>
+                    </a:solidFill>
+                  </a:tcPr>
+                </a:tc>
+                <a:tc>
+                  <a:txBody>
+                    <a:bodyPr/>
+                    <a:lstStyle/>
+                    <a:p>
+                      <a:pPr algn="ctr"/>
+                      <a:r>
+                        <a:rPr sz="1100" b="0">
+                          <a:solidFill>
+                            <a:srgbClr val="1C1C24"/>
+                          </a:solidFill>
+                          <a:latin typeface="Segoe UI"/>
+                        </a:rPr>
+                        <a:t>-0.6402</a:t>
+                      </a:r>
+                    </a:p>
+                  </a:txBody>
+                  <a:tcPr marL="54864" marR="54864" marT="9144" marB="9144">
+                    <a:solidFill>
+                      <a:srgbClr val="FFFFFF"/>
+                    </a:solidFill>
+                  </a:tcPr>
+                </a:tc>
               </a:tr>
-              <a:tr h="246888">
+              <a:tr h="251460">
                 <a:tc>
                   <a:txBody>
                     <a:bodyPr/>
@@ -15578,7 +16745,7 @@
                           </a:solidFill>
                           <a:latin typeface="Segoe UI"/>
                         </a:rPr>
-                        <a:t>mouth</a:t>
+                        <a:t>lips</a:t>
                       </a:r>
                     </a:p>
                   </a:txBody>
@@ -15601,7 +16768,7 @@
                           </a:solidFill>
                           <a:latin typeface="Segoe UI"/>
                         </a:rPr>
-                        <a:t>0.0244</a:t>
+                        <a:t>27</a:t>
                       </a:r>
                     </a:p>
                   </a:txBody>
@@ -15624,7 +16791,7 @@
                           </a:solidFill>
                           <a:latin typeface="Segoe UI"/>
                         </a:rPr>
-                        <a:t>0.0237</a:t>
+                        <a:t>13.7%</a:t>
                       </a:r>
                     </a:p>
                   </a:txBody>
@@ -15647,7 +16814,7 @@
                           </a:solidFill>
                           <a:latin typeface="Segoe UI"/>
                         </a:rPr>
-                        <a:t>-0.0007</a:t>
+                        <a:t>+0.3299</a:t>
                       </a:r>
                     </a:p>
                   </a:txBody>
@@ -15657,8 +16824,54 @@
                     </a:solidFill>
                   </a:tcPr>
                 </a:tc>
+                <a:tc>
+                  <a:txBody>
+                    <a:bodyPr/>
+                    <a:lstStyle/>
+                    <a:p>
+                      <a:pPr algn="ctr"/>
+                      <a:r>
+                        <a:rPr sz="1100" b="0">
+                          <a:solidFill>
+                            <a:srgbClr val="1C1C24"/>
+                          </a:solidFill>
+                          <a:latin typeface="Segoe UI"/>
+                        </a:rPr>
+                        <a:t>3.6%</a:t>
+                      </a:r>
+                    </a:p>
+                  </a:txBody>
+                  <a:tcPr marL="54864" marR="54864" marT="9144" marB="9144">
+                    <a:solidFill>
+                      <a:srgbClr val="F2F4F8"/>
+                    </a:solidFill>
+                  </a:tcPr>
+                </a:tc>
+                <a:tc>
+                  <a:txBody>
+                    <a:bodyPr/>
+                    <a:lstStyle/>
+                    <a:p>
+                      <a:pPr algn="ctr"/>
+                      <a:r>
+                        <a:rPr sz="1100" b="0">
+                          <a:solidFill>
+                            <a:srgbClr val="1C1C24"/>
+                          </a:solidFill>
+                          <a:latin typeface="Segoe UI"/>
+                        </a:rPr>
+                        <a:t>+0.0416</a:t>
+                      </a:r>
+                    </a:p>
+                  </a:txBody>
+                  <a:tcPr marL="54864" marR="54864" marT="9144" marB="9144">
+                    <a:solidFill>
+                      <a:srgbClr val="F2F4F8"/>
+                    </a:solidFill>
+                  </a:tcPr>
+                </a:tc>
               </a:tr>
-              <a:tr h="246888">
+              <a:tr h="251460">
                 <a:tc>
                   <a:txBody>
                     <a:bodyPr/>
@@ -15672,7 +16885,7 @@
                           </a:solidFill>
                           <a:latin typeface="Segoe UI"/>
                         </a:rPr>
-                        <a:t>jaw / contour</a:t>
+                        <a:t>skin</a:t>
                       </a:r>
                     </a:p>
                   </a:txBody>
@@ -15695,7 +16908,7 @@
                           </a:solidFill>
                           <a:latin typeface="Segoe UI"/>
                         </a:rPr>
-                        <a:t>0.0488</a:t>
+                        <a:t>70</a:t>
                       </a:r>
                     </a:p>
                   </a:txBody>
@@ -15718,7 +16931,7 @@
                           </a:solidFill>
                           <a:latin typeface="Segoe UI"/>
                         </a:rPr>
-                        <a:t>0.0306</a:t>
+                        <a:t>33.0%</a:t>
                       </a:r>
                     </a:p>
                   </a:txBody>
@@ -15741,7 +16954,53 @@
                           </a:solidFill>
                           <a:latin typeface="Segoe UI"/>
                         </a:rPr>
-                        <a:t>-0.0182</a:t>
+                        <a:t>+0.7955</a:t>
+                      </a:r>
+                    </a:p>
+                  </a:txBody>
+                  <a:tcPr marL="54864" marR="54864" marT="9144" marB="9144">
+                    <a:solidFill>
+                      <a:srgbClr val="FFFFFF"/>
+                    </a:solidFill>
+                  </a:tcPr>
+                </a:tc>
+                <a:tc>
+                  <a:txBody>
+                    <a:bodyPr/>
+                    <a:lstStyle/>
+                    <a:p>
+                      <a:pPr algn="ctr"/>
+                      <a:r>
+                        <a:rPr sz="1100" b="0">
+                          <a:solidFill>
+                            <a:srgbClr val="1C1C24"/>
+                          </a:solidFill>
+                          <a:latin typeface="Segoe UI"/>
+                        </a:rPr>
+                        <a:t>2.9%</a:t>
+                      </a:r>
+                    </a:p>
+                  </a:txBody>
+                  <a:tcPr marL="54864" marR="54864" marT="9144" marB="9144">
+                    <a:solidFill>
+                      <a:srgbClr val="FFFFFF"/>
+                    </a:solidFill>
+                  </a:tcPr>
+                </a:tc>
+                <a:tc>
+                  <a:txBody>
+                    <a:bodyPr/>
+                    <a:lstStyle/>
+                    <a:p>
+                      <a:pPr algn="ctr"/>
+                      <a:r>
+                        <a:rPr sz="1100" b="0">
+                          <a:solidFill>
+                            <a:srgbClr val="1C1C24"/>
+                          </a:solidFill>
+                          <a:latin typeface="Segoe UI"/>
+                        </a:rPr>
+                        <a:t>+0.0337</a:t>
                       </a:r>
                     </a:p>
                   </a:txBody>
@@ -15758,14 +17017,14 @@
       </p:graphicFrame>
       <p:sp>
         <p:nvSpPr>
-          <p:cNvPr id="9" name="TextBox 8"/>
+          <p:cNvPr id="8" name="TextBox 7"/>
           <p:cNvSpPr txBox="1"/>
           <p:nvPr/>
         </p:nvSpPr>
         <p:spPr>
           <a:xfrm>
-            <a:off x="6172200" y="6025896"/>
-            <a:ext cx="5449824" cy="548640"/>
+            <a:off x="566928" y="5875019"/>
+            <a:ext cx="11057839" cy="777240"/>
           </a:xfrm>
           <a:prstGeom prst="rect">
             <a:avLst/>
@@ -15780,20 +17039,39 @@
           <a:p>
             <a:pPr algn="l">
               <a:lnSpc>
-                <a:spcPct val="122000"/>
+                <a:spcPct val="126000"/>
               </a:lnSpc>
               <a:spcAft>
                 <a:spcPts val="500"/>
               </a:spcAft>
             </a:pPr>
             <a:r>
-              <a:rPr sz="1150" b="0" i="0">
+              <a:rPr sz="1200" b="0" i="0">
                 <a:solidFill>
                   <a:srgbClr val="1C1C24"/>
                 </a:solidFill>
                 <a:latin typeface="Segoe UI"/>
               </a:rPr>
-              <a:t>Biggest gains after the swap: eyes, nose, mouth — the same inner-face region the swap replaced.</a:t>
+              <a:t>•  Same conclusion, now spatially localised: the EYE patches carry 47.7% of the FAKE evidence, skin 33.0%.</a:t>
+            </a:r>
+          </a:p>
+          <a:p>
+            <a:pPr algn="l">
+              <a:lnSpc>
+                <a:spcPct val="126000"/>
+              </a:lnSpc>
+              <a:spcAft>
+                <a:spcPts val="500"/>
+              </a:spcAft>
+            </a:pPr>
+            <a:r>
+              <a:rPr sz="1200" b="0" i="0">
+                <a:solidFill>
+                  <a:srgbClr val="1C1C24"/>
+                </a:solidFill>
+                <a:latin typeface="Segoe UI"/>
+              </a:rPr>
+              <a:t>•  In the REAL video the NOSE patches dominate (55.7%) and vote REAL (-0.6402). Exact: contributions sum to the head logit (error 4e-16).</a:t>
             </a:r>
           </a:p>
         </p:txBody>
@@ -15905,7 +17183,7 @@
                 </a:solidFill>
                 <a:latin typeface="Segoe UI"/>
               </a:rPr>
-              <a:t>RESULT 5</a:t>
+              <a:t>RESULT 3C</a:t>
             </a:r>
           </a:p>
         </p:txBody>
@@ -15947,7 +17225,7 @@
                 </a:solidFill>
                 <a:latin typeface="Segoe UI"/>
               </a:rPr>
-              <a:t>Zone attribution and component attention</a:t>
+              <a:t>Do the two views agree? And where does each branch look?</a:t>
             </a:r>
           </a:p>
         </p:txBody>
@@ -15989,14 +17267,14 @@
                 </a:solidFill>
                 <a:latin typeface="Segoe UI"/>
               </a:rPr>
-              <a:t>Area-normalising removes the advantage of physically large regions</a:t>
+              <a:t>Validating the region attribution, and comparing both branches on identical regions</a:t>
             </a:r>
           </a:p>
         </p:txBody>
       </p:sp>
       <p:pic>
         <p:nvPicPr>
-          <p:cNvPr id="6" name="Picture 5" descr="f6_zones.png"/>
+          <p:cNvPr id="6" name="Picture 5" descr="f12_region_validation.png"/>
           <p:cNvPicPr>
             <a:picLocks noChangeAspect="1"/>
           </p:cNvPicPr>
@@ -16010,24 +17288,522 @@
         </p:blipFill>
         <p:spPr>
           <a:xfrm>
-            <a:off x="2364835" y="1554480"/>
-            <a:ext cx="7462024" cy="2514600"/>
+            <a:off x="1890580" y="1554480"/>
+            <a:ext cx="8410534" cy="2514600"/>
           </a:xfrm>
           <a:prstGeom prst="rect">
             <a:avLst/>
           </a:prstGeom>
         </p:spPr>
       </p:pic>
-      <p:sp>
-        <p:nvSpPr>
-          <p:cNvPr id="7" name="TextBox 6"/>
+      <p:graphicFrame>
+        <p:nvGraphicFramePr>
+          <p:cNvPr id="7" name="Table 6"/>
+          <p:cNvGraphicFramePr>
+            <a:graphicFrameLocks noGrp="1"/>
+          </p:cNvGraphicFramePr>
+          <p:nvPr/>
+        </p:nvGraphicFramePr>
+        <p:xfrm>
+          <a:off x="566928" y="4178808"/>
+          <a:ext cx="5577838" cy="1188720"/>
+        </p:xfrm>
+        <a:graphic>
+          <a:graphicData uri="http://schemas.openxmlformats.org/drawingml/2006/table">
+            <a:tbl>
+              <a:tblPr firstRow="1" bandRow="1">
+                <a:tableStyleId>{5C22544A-7EE6-4342-B048-85BDC9FD1C3A}</a:tableStyleId>
+              </a:tblPr>
+              <a:tblGrid>
+                <a:gridCol w="1248770"/>
+                <a:gridCol w="1914780"/>
+                <a:gridCol w="1248770"/>
+                <a:gridCol w="1165518"/>
+              </a:tblGrid>
+              <a:tr h="237744">
+                <a:tc>
+                  <a:txBody>
+                    <a:bodyPr/>
+                    <a:lstStyle/>
+                    <a:p>
+                      <a:pPr algn="l"/>
+                      <a:r>
+                        <a:rPr sz="1100" b="1">
+                          <a:solidFill>
+                            <a:srgbClr val="FFFFFF"/>
+                          </a:solidFill>
+                          <a:latin typeface="Segoe UI"/>
+                        </a:rPr>
+                        <a:t>query (named)</a:t>
+                      </a:r>
+                    </a:p>
+                  </a:txBody>
+                  <a:tcPr marL="54864" marR="54864" marT="9144" marB="9144">
+                    <a:solidFill>
+                      <a:srgbClr val="2E6FD9"/>
+                    </a:solidFill>
+                  </a:tcPr>
+                </a:tc>
+                <a:tc>
+                  <a:txBody>
+                    <a:bodyPr/>
+                    <a:lstStyle/>
+                    <a:p>
+                      <a:pPr algn="ctr"/>
+                      <a:r>
+                        <a:rPr sz="1100" b="1">
+                          <a:solidFill>
+                            <a:srgbClr val="FFFFFF"/>
+                          </a:solidFill>
+                          <a:latin typeface="Segoe UI"/>
+                        </a:rPr>
+                        <a:t>evidence from its OWN region</a:t>
+                      </a:r>
+                    </a:p>
+                  </a:txBody>
+                  <a:tcPr marL="54864" marR="54864" marT="9144" marB="9144">
+                    <a:solidFill>
+                      <a:srgbClr val="2E6FD9"/>
+                    </a:solidFill>
+                  </a:tcPr>
+                </a:tc>
+                <a:tc>
+                  <a:txBody>
+                    <a:bodyPr/>
+                    <a:lstStyle/>
+                    <a:p>
+                      <a:pPr algn="ctr"/>
+                      <a:r>
+                        <a:rPr sz="1100" b="1">
+                          <a:solidFill>
+                            <a:srgbClr val="FFFFFF"/>
+                          </a:solidFill>
+                          <a:latin typeface="Segoe UI"/>
+                        </a:rPr>
+                        <a:t>strongest region</a:t>
+                      </a:r>
+                    </a:p>
+                  </a:txBody>
+                  <a:tcPr marL="54864" marR="54864" marT="9144" marB="9144">
+                    <a:solidFill>
+                      <a:srgbClr val="2E6FD9"/>
+                    </a:solidFill>
+                  </a:tcPr>
+                </a:tc>
+                <a:tc>
+                  <a:txBody>
+                    <a:bodyPr/>
+                    <a:lstStyle/>
+                    <a:p>
+                      <a:pPr algn="ctr"/>
+                      <a:r>
+                        <a:rPr sz="1100" b="1">
+                          <a:solidFill>
+                            <a:srgbClr val="FFFFFF"/>
+                          </a:solidFill>
+                          <a:latin typeface="Segoe UI"/>
+                        </a:rPr>
+                        <a:t>verdict</a:t>
+                      </a:r>
+                    </a:p>
+                  </a:txBody>
+                  <a:tcPr marL="54864" marR="54864" marT="9144" marB="9144">
+                    <a:solidFill>
+                      <a:srgbClr val="2E6FD9"/>
+                    </a:solidFill>
+                  </a:tcPr>
+                </a:tc>
+              </a:tr>
+              <a:tr h="237744">
+                <a:tc>
+                  <a:txBody>
+                    <a:bodyPr/>
+                    <a:lstStyle/>
+                    <a:p>
+                      <a:pPr algn="l"/>
+                      <a:r>
+                        <a:rPr sz="1100" b="0">
+                          <a:solidFill>
+                            <a:srgbClr val="1C1C24"/>
+                          </a:solidFill>
+                          <a:latin typeface="Segoe UI"/>
+                        </a:rPr>
+                        <a:t>eyes</a:t>
+                      </a:r>
+                    </a:p>
+                  </a:txBody>
+                  <a:tcPr marL="54864" marR="54864" marT="9144" marB="9144">
+                    <a:solidFill>
+                      <a:srgbClr val="F2F4F8"/>
+                    </a:solidFill>
+                  </a:tcPr>
+                </a:tc>
+                <a:tc>
+                  <a:txBody>
+                    <a:bodyPr/>
+                    <a:lstStyle/>
+                    <a:p>
+                      <a:pPr algn="ctr"/>
+                      <a:r>
+                        <a:rPr sz="1100" b="0">
+                          <a:solidFill>
+                            <a:srgbClr val="1C1C24"/>
+                          </a:solidFill>
+                          <a:latin typeface="Segoe UI"/>
+                        </a:rPr>
+                        <a:t>88.6%</a:t>
+                      </a:r>
+                    </a:p>
+                  </a:txBody>
+                  <a:tcPr marL="54864" marR="54864" marT="9144" marB="9144">
+                    <a:solidFill>
+                      <a:srgbClr val="F2F4F8"/>
+                    </a:solidFill>
+                  </a:tcPr>
+                </a:tc>
+                <a:tc>
+                  <a:txBody>
+                    <a:bodyPr/>
+                    <a:lstStyle/>
+                    <a:p>
+                      <a:pPr algn="ctr"/>
+                      <a:r>
+                        <a:rPr sz="1100" b="0">
+                          <a:solidFill>
+                            <a:srgbClr val="1C1C24"/>
+                          </a:solidFill>
+                          <a:latin typeface="Segoe UI"/>
+                        </a:rPr>
+                        <a:t>eyes</a:t>
+                      </a:r>
+                    </a:p>
+                  </a:txBody>
+                  <a:tcPr marL="54864" marR="54864" marT="9144" marB="9144">
+                    <a:solidFill>
+                      <a:srgbClr val="F2F4F8"/>
+                    </a:solidFill>
+                  </a:tcPr>
+                </a:tc>
+                <a:tc>
+                  <a:txBody>
+                    <a:bodyPr/>
+                    <a:lstStyle/>
+                    <a:p>
+                      <a:pPr algn="ctr"/>
+                      <a:r>
+                        <a:rPr sz="1100" b="0">
+                          <a:solidFill>
+                            <a:srgbClr val="1C1C24"/>
+                          </a:solidFill>
+                          <a:latin typeface="Segoe UI"/>
+                        </a:rPr>
+                        <a:t>localised ✓</a:t>
+                      </a:r>
+                    </a:p>
+                  </a:txBody>
+                  <a:tcPr marL="54864" marR="54864" marT="9144" marB="9144">
+                    <a:solidFill>
+                      <a:srgbClr val="F2F4F8"/>
+                    </a:solidFill>
+                  </a:tcPr>
+                </a:tc>
+              </a:tr>
+              <a:tr h="237744">
+                <a:tc>
+                  <a:txBody>
+                    <a:bodyPr/>
+                    <a:lstStyle/>
+                    <a:p>
+                      <a:pPr algn="l"/>
+                      <a:r>
+                        <a:rPr sz="1100" b="0">
+                          <a:solidFill>
+                            <a:srgbClr val="1C1C24"/>
+                          </a:solidFill>
+                          <a:latin typeface="Segoe UI"/>
+                        </a:rPr>
+                        <a:t>skin</a:t>
+                      </a:r>
+                    </a:p>
+                  </a:txBody>
+                  <a:tcPr marL="54864" marR="54864" marT="9144" marB="9144">
+                    <a:solidFill>
+                      <a:srgbClr val="FFFFFF"/>
+                    </a:solidFill>
+                  </a:tcPr>
+                </a:tc>
+                <a:tc>
+                  <a:txBody>
+                    <a:bodyPr/>
+                    <a:lstStyle/>
+                    <a:p>
+                      <a:pPr algn="ctr"/>
+                      <a:r>
+                        <a:rPr sz="1100" b="0">
+                          <a:solidFill>
+                            <a:srgbClr val="1C1C24"/>
+                          </a:solidFill>
+                          <a:latin typeface="Segoe UI"/>
+                        </a:rPr>
+                        <a:t>79.5%</a:t>
+                      </a:r>
+                    </a:p>
+                  </a:txBody>
+                  <a:tcPr marL="54864" marR="54864" marT="9144" marB="9144">
+                    <a:solidFill>
+                      <a:srgbClr val="FFFFFF"/>
+                    </a:solidFill>
+                  </a:tcPr>
+                </a:tc>
+                <a:tc>
+                  <a:txBody>
+                    <a:bodyPr/>
+                    <a:lstStyle/>
+                    <a:p>
+                      <a:pPr algn="ctr"/>
+                      <a:r>
+                        <a:rPr sz="1100" b="0">
+                          <a:solidFill>
+                            <a:srgbClr val="1C1C24"/>
+                          </a:solidFill>
+                          <a:latin typeface="Segoe UI"/>
+                        </a:rPr>
+                        <a:t>skin</a:t>
+                      </a:r>
+                    </a:p>
+                  </a:txBody>
+                  <a:tcPr marL="54864" marR="54864" marT="9144" marB="9144">
+                    <a:solidFill>
+                      <a:srgbClr val="FFFFFF"/>
+                    </a:solidFill>
+                  </a:tcPr>
+                </a:tc>
+                <a:tc>
+                  <a:txBody>
+                    <a:bodyPr/>
+                    <a:lstStyle/>
+                    <a:p>
+                      <a:pPr algn="ctr"/>
+                      <a:r>
+                        <a:rPr sz="1100" b="0">
+                          <a:solidFill>
+                            <a:srgbClr val="1C1C24"/>
+                          </a:solidFill>
+                          <a:latin typeface="Segoe UI"/>
+                        </a:rPr>
+                        <a:t>localised ✓</a:t>
+                      </a:r>
+                    </a:p>
+                  </a:txBody>
+                  <a:tcPr marL="54864" marR="54864" marT="9144" marB="9144">
+                    <a:solidFill>
+                      <a:srgbClr val="FFFFFF"/>
+                    </a:solidFill>
+                  </a:tcPr>
+                </a:tc>
+              </a:tr>
+              <a:tr h="237744">
+                <a:tc>
+                  <a:txBody>
+                    <a:bodyPr/>
+                    <a:lstStyle/>
+                    <a:p>
+                      <a:pPr algn="l"/>
+                      <a:r>
+                        <a:rPr sz="1100" b="0">
+                          <a:solidFill>
+                            <a:srgbClr val="1C1C24"/>
+                          </a:solidFill>
+                          <a:latin typeface="Segoe UI"/>
+                        </a:rPr>
+                        <a:t>lips</a:t>
+                      </a:r>
+                    </a:p>
+                  </a:txBody>
+                  <a:tcPr marL="54864" marR="54864" marT="9144" marB="9144">
+                    <a:solidFill>
+                      <a:srgbClr val="F2F4F8"/>
+                    </a:solidFill>
+                  </a:tcPr>
+                </a:tc>
+                <a:tc>
+                  <a:txBody>
+                    <a:bodyPr/>
+                    <a:lstStyle/>
+                    <a:p>
+                      <a:pPr algn="ctr"/>
+                      <a:r>
+                        <a:rPr sz="1100" b="0">
+                          <a:solidFill>
+                            <a:srgbClr val="1C1C24"/>
+                          </a:solidFill>
+                          <a:latin typeface="Segoe UI"/>
+                        </a:rPr>
+                        <a:t>86.0%</a:t>
+                      </a:r>
+                    </a:p>
+                  </a:txBody>
+                  <a:tcPr marL="54864" marR="54864" marT="9144" marB="9144">
+                    <a:solidFill>
+                      <a:srgbClr val="F2F4F8"/>
+                    </a:solidFill>
+                  </a:tcPr>
+                </a:tc>
+                <a:tc>
+                  <a:txBody>
+                    <a:bodyPr/>
+                    <a:lstStyle/>
+                    <a:p>
+                      <a:pPr algn="ctr"/>
+                      <a:r>
+                        <a:rPr sz="1100" b="0">
+                          <a:solidFill>
+                            <a:srgbClr val="1C1C24"/>
+                          </a:solidFill>
+                          <a:latin typeface="Segoe UI"/>
+                        </a:rPr>
+                        <a:t>lips</a:t>
+                      </a:r>
+                    </a:p>
+                  </a:txBody>
+                  <a:tcPr marL="54864" marR="54864" marT="9144" marB="9144">
+                    <a:solidFill>
+                      <a:srgbClr val="F2F4F8"/>
+                    </a:solidFill>
+                  </a:tcPr>
+                </a:tc>
+                <a:tc>
+                  <a:txBody>
+                    <a:bodyPr/>
+                    <a:lstStyle/>
+                    <a:p>
+                      <a:pPr algn="ctr"/>
+                      <a:r>
+                        <a:rPr sz="1100" b="0">
+                          <a:solidFill>
+                            <a:srgbClr val="1C1C24"/>
+                          </a:solidFill>
+                          <a:latin typeface="Segoe UI"/>
+                        </a:rPr>
+                        <a:t>localised ✓</a:t>
+                      </a:r>
+                    </a:p>
+                  </a:txBody>
+                  <a:tcPr marL="54864" marR="54864" marT="9144" marB="9144">
+                    <a:solidFill>
+                      <a:srgbClr val="F2F4F8"/>
+                    </a:solidFill>
+                  </a:tcPr>
+                </a:tc>
+              </a:tr>
+              <a:tr h="237744">
+                <a:tc>
+                  <a:txBody>
+                    <a:bodyPr/>
+                    <a:lstStyle/>
+                    <a:p>
+                      <a:pPr algn="l"/>
+                      <a:r>
+                        <a:rPr sz="1100" b="0">
+                          <a:solidFill>
+                            <a:srgbClr val="1C1C24"/>
+                          </a:solidFill>
+                          <a:latin typeface="Segoe UI"/>
+                        </a:rPr>
+                        <a:t>nose</a:t>
+                      </a:r>
+                    </a:p>
+                  </a:txBody>
+                  <a:tcPr marL="54864" marR="54864" marT="9144" marB="9144">
+                    <a:solidFill>
+                      <a:srgbClr val="FFFFFF"/>
+                    </a:solidFill>
+                  </a:tcPr>
+                </a:tc>
+                <a:tc>
+                  <a:txBody>
+                    <a:bodyPr/>
+                    <a:lstStyle/>
+                    <a:p>
+                      <a:pPr algn="ctr"/>
+                      <a:r>
+                        <a:rPr sz="1100" b="0">
+                          <a:solidFill>
+                            <a:srgbClr val="1C1C24"/>
+                          </a:solidFill>
+                          <a:latin typeface="Segoe UI"/>
+                        </a:rPr>
+                        <a:t>9.1%</a:t>
+                      </a:r>
+                    </a:p>
+                  </a:txBody>
+                  <a:tcPr marL="54864" marR="54864" marT="9144" marB="9144">
+                    <a:solidFill>
+                      <a:srgbClr val="FFFFFF"/>
+                    </a:solidFill>
+                  </a:tcPr>
+                </a:tc>
+                <a:tc>
+                  <a:txBody>
+                    <a:bodyPr/>
+                    <a:lstStyle/>
+                    <a:p>
+                      <a:pPr algn="ctr"/>
+                      <a:r>
+                        <a:rPr sz="1100" b="0">
+                          <a:solidFill>
+                            <a:srgbClr val="1C1C24"/>
+                          </a:solidFill>
+                          <a:latin typeface="Segoe UI"/>
+                        </a:rPr>
+                        <a:t>skin</a:t>
+                      </a:r>
+                    </a:p>
+                  </a:txBody>
+                  <a:tcPr marL="54864" marR="54864" marT="9144" marB="9144">
+                    <a:solidFill>
+                      <a:srgbClr val="FFFFFF"/>
+                    </a:solidFill>
+                  </a:tcPr>
+                </a:tc>
+                <a:tc>
+                  <a:txBody>
+                    <a:bodyPr/>
+                    <a:lstStyle/>
+                    <a:p>
+                      <a:pPr algn="ctr"/>
+                      <a:r>
+                        <a:rPr sz="1100" b="0">
+                          <a:solidFill>
+                            <a:srgbClr val="1C1C24"/>
+                          </a:solidFill>
+                          <a:latin typeface="Segoe UI"/>
+                        </a:rPr>
+                        <a:t>DRIFTED ✗</a:t>
+                      </a:r>
+                    </a:p>
+                  </a:txBody>
+                  <a:tcPr marL="54864" marR="54864" marT="9144" marB="9144">
+                    <a:solidFill>
+                      <a:srgbClr val="FFFFFF"/>
+                    </a:solidFill>
+                  </a:tcPr>
+                </a:tc>
+              </a:tr>
+            </a:tbl>
+          </a:graphicData>
+        </a:graphic>
+      </p:graphicFrame>
+      <p:sp>
+        <p:nvSpPr>
+          <p:cNvPr id="8" name="TextBox 7"/>
           <p:cNvSpPr txBox="1"/>
           <p:nvPr/>
         </p:nvSpPr>
         <p:spPr>
           <a:xfrm>
-            <a:off x="566928" y="4178808"/>
-            <a:ext cx="2057400" cy="2377440"/>
+            <a:off x="6355080" y="4178808"/>
+            <a:ext cx="5266944" cy="1463040"/>
           </a:xfrm>
           <a:prstGeom prst="rect">
             <a:avLst/>
@@ -16042,7 +17818,7 @@
           <a:p>
             <a:pPr algn="l">
               <a:lnSpc>
-                <a:spcPct val="122000"/>
+                <a:spcPct val="120000"/>
               </a:lnSpc>
               <a:spcAft>
                 <a:spcPts val="500"/>
@@ -16055,13 +17831,13 @@
                 </a:solidFill>
                 <a:latin typeface="Segoe UI"/>
               </a:rPr>
-              <a:t>Sanity check on FCG:</a:t>
+              <a:t>Two findings:</a:t>
             </a:r>
           </a:p>
           <a:p>
             <a:pPr algn="l">
               <a:lnSpc>
-                <a:spcPct val="122000"/>
+                <a:spcPct val="120000"/>
               </a:lnSpc>
               <a:spcAft>
                 <a:spcPts val="500"/>
@@ -16074,13 +17850,13 @@
                 </a:solidFill>
                 <a:latin typeface="Segoe UI"/>
               </a:rPr>
-              <a:t>•  each of the four queries lands on its own region,</a:t>
+              <a:t>•  Both decompositions agree EYES dominate the fake — independent methods, same conclusion.</a:t>
             </a:r>
           </a:p>
           <a:p>
             <a:pPr algn="l">
               <a:lnSpc>
-                <a:spcPct val="122000"/>
+                <a:spcPct val="120000"/>
               </a:lnSpc>
               <a:spcAft>
                 <a:spcPts val="500"/>
@@ -16093,13 +17869,36 @@
                 </a:solidFill>
                 <a:latin typeface="Segoe UI"/>
               </a:rPr>
-              <a:t>•  so the component percentages are anatomically meaningful,</a:t>
-            </a:r>
-          </a:p>
+              <a:t>•  3 of 4 FCG queries sit on their own anatomy; the NOSE query drifts onto SKIN once the face is swapped (86% → 9%).</a:t>
+            </a:r>
+          </a:p>
+        </p:txBody>
+      </p:sp>
+      <p:sp>
+        <p:nvSpPr>
+          <p:cNvPr id="9" name="TextBox 8"/>
+          <p:cNvSpPr txBox="1"/>
+          <p:nvPr/>
+        </p:nvSpPr>
+        <p:spPr>
+          <a:xfrm>
+            <a:off x="566928" y="5477256"/>
+            <a:ext cx="11057839" cy="566928"/>
+          </a:xfrm>
+          <a:prstGeom prst="rect">
+            <a:avLst/>
+          </a:prstGeom>
+          <a:noFill/>
+        </p:spPr>
+        <p:txBody>
+          <a:bodyPr wrap="square" lIns="0" rIns="0" tIns="0" bIns="0">
+            <a:spAutoFit/>
+          </a:bodyPr>
+          <a:lstStyle/>
           <a:p>
             <a:pPr algn="l">
               <a:lnSpc>
-                <a:spcPct val="122000"/>
+                <a:spcPct val="120000"/>
               </a:lnSpc>
               <a:spcAft>
                 <a:spcPts val="500"/>
@@ -16112,35 +17911,11 @@
                 </a:solidFill>
                 <a:latin typeface="Segoe UI"/>
               </a:rPr>
-              <a:t>•  not four anonymous channels.</a:t>
-            </a:r>
-          </a:p>
-        </p:txBody>
-      </p:sp>
-      <p:pic>
-        <p:nvPicPr>
-          <p:cNvPr id="8" name="Picture 7" descr="f8_attention.png"/>
-          <p:cNvPicPr>
-            <a:picLocks noChangeAspect="1"/>
-          </p:cNvPicPr>
-          <p:nvPr/>
-        </p:nvPicPr>
-        <p:blipFill>
-          <a:blip r:embed="rId3"/>
-          <a:stretch>
-            <a:fillRect/>
-          </a:stretch>
-        </p:blipFill>
-        <p:spPr>
-          <a:xfrm>
-            <a:off x="4991976" y="4178808"/>
-            <a:ext cx="4426991" cy="2386583"/>
-          </a:xfrm>
-          <a:prstGeom prst="rect">
-            <a:avLst/>
-          </a:prstGeom>
-        </p:spPr>
-      </p:pic>
+              <a:t>•  The branches read DIFFERENT regions: for the fake, spatial favours eyes (47.7%) while temporal favours skin (41.9%) — they are not duplicating each other.</a:t>
+            </a:r>
+          </a:p>
+        </p:txBody>
+      </p:sp>
     </p:spTree>
   </p:cSld>
   <p:clrMapOvr>
@@ -16248,7 +18023,7 @@
                 </a:solidFill>
                 <a:latin typeface="Segoe UI"/>
               </a:rPr>
-              <a:t>RESULT 6</a:t>
+              <a:t>RESULT 4</a:t>
             </a:r>
           </a:p>
         </p:txBody>
@@ -16290,7 +18065,7 @@
                 </a:solidFill>
                 <a:latin typeface="Segoe UI"/>
               </a:rPr>
-              <a:t>Is one branch enough?</a:t>
+              <a:t>Where in the face the temporal evidence lies</a:t>
             </a:r>
           </a:p>
         </p:txBody>
@@ -16332,14 +18107,14 @@
                 </a:solidFill>
                 <a:latin typeface="Segoe UI"/>
               </a:rPr>
-              <a:t>Inference-time ablation of the released checkpoint</a:t>
+              <a:t>The temporal branch output is a 16×16 grid, so it maps straight back onto the face</a:t>
             </a:r>
           </a:p>
         </p:txBody>
       </p:sp>
       <p:pic>
         <p:nvPicPr>
-          <p:cNvPr id="6" name="Picture 5" descr="f9_counterfactual.png"/>
+          <p:cNvPr id="6" name="Picture 5" descr="f5_temporal_maps.png"/>
           <p:cNvPicPr>
             <a:picLocks noChangeAspect="1"/>
           </p:cNvPicPr>
@@ -16353,8 +18128,8 @@
         </p:blipFill>
         <p:spPr>
           <a:xfrm>
-            <a:off x="566928" y="1554480"/>
-            <a:ext cx="7315200" cy="2414986"/>
+            <a:off x="1457278" y="1554480"/>
+            <a:ext cx="9277138" cy="3017520"/>
           </a:xfrm>
           <a:prstGeom prst="rect">
             <a:avLst/>
@@ -16363,60 +18138,14 @@
       </p:pic>
       <p:sp>
         <p:nvSpPr>
-          <p:cNvPr id="7" name="Rounded Rectangle 6"/>
-          <p:cNvSpPr/>
+          <p:cNvPr id="7" name="TextBox 6"/>
+          <p:cNvSpPr txBox="1"/>
           <p:nvPr/>
         </p:nvSpPr>
         <p:spPr>
           <a:xfrm>
-            <a:off x="8092440" y="1554480"/>
-            <a:ext cx="3529584" cy="1170432"/>
-          </a:xfrm>
-          <a:prstGeom prst="roundRect">
-            <a:avLst/>
-          </a:prstGeom>
-          <a:solidFill>
-            <a:srgbClr val="F2F4F8"/>
-          </a:solidFill>
-          <a:ln w="15240">
-            <a:solidFill>
-              <a:srgbClr val="1E7A3C"/>
-            </a:solidFill>
-          </a:ln>
-          <a:effectLst/>
-        </p:spPr>
-        <p:style>
-          <a:lnRef idx="1">
-            <a:schemeClr val="accent1"/>
-          </a:lnRef>
-          <a:fillRef idx="3">
-            <a:schemeClr val="accent1"/>
-          </a:fillRef>
-          <a:effectRef idx="2">
-            <a:schemeClr val="accent1"/>
-          </a:effectRef>
-          <a:fontRef idx="minor">
-            <a:schemeClr val="lt1"/>
-          </a:fontRef>
-        </p:style>
-        <p:txBody>
-          <a:bodyPr rtlCol="0" anchor="ctr"/>
-          <a:lstStyle/>
-          <a:p>
-            <a:pPr algn="ctr"/>
-          </a:p>
-        </p:txBody>
-      </p:sp>
-      <p:sp>
-        <p:nvSpPr>
-          <p:cNvPr id="8" name="TextBox 7"/>
-          <p:cNvSpPr txBox="1"/>
-          <p:nvPr/>
-        </p:nvSpPr>
-        <p:spPr>
-          <a:xfrm>
-            <a:off x="8275319" y="1682496"/>
-            <a:ext cx="3163824" cy="237744"/>
+            <a:off x="566928" y="4700016"/>
+            <a:ext cx="5349240" cy="1737360"/>
           </a:xfrm>
           <a:prstGeom prst="rect">
             <a:avLst/>
@@ -16431,290 +18160,589 @@
           <a:p>
             <a:pPr algn="l">
               <a:lnSpc>
-                <a:spcPct val="114000"/>
+                <a:spcPct val="124000"/>
               </a:lnSpc>
               <a:spcAft>
                 <a:spcPts val="500"/>
               </a:spcAft>
             </a:pPr>
             <a:r>
-              <a:rPr sz="1000" b="1" i="0">
-                <a:solidFill>
-                  <a:srgbClr val="5A5F6E"/>
+              <a:rPr sz="1150" b="0" i="0">
+                <a:solidFill>
+                  <a:srgbClr val="1C1C24"/>
                 </a:solidFill>
                 <a:latin typeface="Segoe UI"/>
               </a:rPr>
-              <a:t>FAKE SAMPLE</a:t>
-            </a:r>
-          </a:p>
-        </p:txBody>
-      </p:sp>
-      <p:sp>
-        <p:nvSpPr>
-          <p:cNvPr id="9" name="TextBox 8"/>
-          <p:cNvSpPr txBox="1"/>
-          <p:nvPr/>
-        </p:nvSpPr>
-        <p:spPr>
-          <a:xfrm>
-            <a:off x="8275319" y="1920240"/>
-            <a:ext cx="3163824" cy="384048"/>
-          </a:xfrm>
-          <a:prstGeom prst="rect">
-            <a:avLst/>
-          </a:prstGeom>
-          <a:noFill/>
-        </p:spPr>
-        <p:txBody>
-          <a:bodyPr wrap="square" lIns="0" rIns="0" tIns="0" bIns="0">
-            <a:spAutoFit/>
-          </a:bodyPr>
-          <a:lstStyle/>
+              <a:t>Reading the maps:</a:t>
+            </a:r>
+          </a:p>
           <a:p>
             <a:pPr algn="l">
               <a:lnSpc>
-                <a:spcPct val="114000"/>
+                <a:spcPct val="124000"/>
               </a:lnSpc>
               <a:spcAft>
                 <a:spcPts val="500"/>
               </a:spcAft>
             </a:pPr>
             <a:r>
-              <a:rPr sz="1600" b="1" i="0">
-                <a:solidFill>
-                  <a:srgbClr val="1E7A3C"/>
+              <a:rPr sz="1150" b="0" i="0">
+                <a:solidFill>
+                  <a:srgbClr val="1C1C24"/>
                 </a:solidFill>
                 <a:latin typeface="Segoe UI"/>
               </a:rPr>
-              <a:t>both sufficient</a:t>
-            </a:r>
-          </a:p>
-        </p:txBody>
-      </p:sp>
-      <p:sp>
-        <p:nvSpPr>
-          <p:cNvPr id="10" name="TextBox 9"/>
-          <p:cNvSpPr txBox="1"/>
-          <p:nvPr/>
-        </p:nvSpPr>
-        <p:spPr>
-          <a:xfrm>
-            <a:off x="8275319" y="2359152"/>
-            <a:ext cx="3163824" cy="256032"/>
-          </a:xfrm>
-          <a:prstGeom prst="rect">
-            <a:avLst/>
-          </a:prstGeom>
-          <a:noFill/>
-        </p:spPr>
-        <p:txBody>
-          <a:bodyPr wrap="square" lIns="0" rIns="0" tIns="0" bIns="0">
-            <a:spAutoFit/>
-          </a:bodyPr>
-          <a:lstStyle/>
+              <a:t>•  red = this patch pushed towards FAKE, blue = towards REAL;</a:t>
+            </a:r>
+          </a:p>
           <a:p>
             <a:pPr algn="l">
               <a:lnSpc>
-                <a:spcPct val="118000"/>
+                <a:spcPct val="124000"/>
               </a:lnSpc>
               <a:spcAft>
                 <a:spcPts val="500"/>
               </a:spcAft>
             </a:pPr>
             <a:r>
-              <a:rPr sz="1050" b="0" i="0">
+              <a:rPr sz="1150" b="0" i="0">
                 <a:solidFill>
                   <a:srgbClr val="1C1C24"/>
                 </a:solidFill>
                 <a:latin typeface="Segoe UI"/>
               </a:rPr>
-              <a:t>S alone 0.912  ·  T alone 0.908</a:t>
-            </a:r>
-          </a:p>
-        </p:txBody>
-      </p:sp>
-      <p:sp>
-        <p:nvSpPr>
-          <p:cNvPr id="11" name="Rounded Rectangle 10"/>
-          <p:cNvSpPr/>
-          <p:nvPr/>
-        </p:nvSpPr>
-        <p:spPr>
-          <a:xfrm>
-            <a:off x="8092440" y="2889504"/>
-            <a:ext cx="3529584" cy="1170432"/>
-          </a:xfrm>
-          <a:prstGeom prst="roundRect">
-            <a:avLst/>
-          </a:prstGeom>
-          <a:solidFill>
-            <a:srgbClr val="F2F4F8"/>
-          </a:solidFill>
-          <a:ln w="15240">
-            <a:solidFill>
-              <a:srgbClr val="2E6FD9"/>
-            </a:solidFill>
-          </a:ln>
-          <a:effectLst/>
-        </p:spPr>
-        <p:style>
-          <a:lnRef idx="1">
-            <a:schemeClr val="accent1"/>
-          </a:lnRef>
-          <a:fillRef idx="3">
-            <a:schemeClr val="accent1"/>
-          </a:fillRef>
-          <a:effectRef idx="2">
-            <a:schemeClr val="accent1"/>
-          </a:effectRef>
-          <a:fontRef idx="minor">
-            <a:schemeClr val="lt1"/>
-          </a:fontRef>
-        </p:style>
-        <p:txBody>
-          <a:bodyPr rtlCol="0" anchor="ctr"/>
-          <a:lstStyle/>
-          <a:p>
-            <a:pPr algn="ctr"/>
-          </a:p>
-        </p:txBody>
-      </p:sp>
-      <p:sp>
-        <p:nvSpPr>
-          <p:cNvPr id="12" name="TextBox 11"/>
-          <p:cNvSpPr txBox="1"/>
-          <p:nvPr/>
-        </p:nvSpPr>
-        <p:spPr>
-          <a:xfrm>
-            <a:off x="8275319" y="3017520"/>
-            <a:ext cx="3163824" cy="237744"/>
-          </a:xfrm>
-          <a:prstGeom prst="rect">
-            <a:avLst/>
-          </a:prstGeom>
-          <a:noFill/>
-        </p:spPr>
-        <p:txBody>
-          <a:bodyPr wrap="square" lIns="0" rIns="0" tIns="0" bIns="0">
-            <a:spAutoFit/>
-          </a:bodyPr>
-          <a:lstStyle/>
+              <a:t>•  green dots are the averaged 68 facial landmarks;</a:t>
+            </a:r>
+          </a:p>
           <a:p>
             <a:pPr algn="l">
               <a:lnSpc>
-                <a:spcPct val="114000"/>
+                <a:spcPct val="124000"/>
               </a:lnSpc>
               <a:spcAft>
                 <a:spcPts val="500"/>
               </a:spcAft>
             </a:pPr>
             <a:r>
-              <a:rPr sz="1000" b="1" i="0">
-                <a:solidFill>
-                  <a:srgbClr val="5A5F6E"/>
+              <a:rPr sz="1150" b="0" i="0">
+                <a:solidFill>
+                  <a:srgbClr val="1C1C24"/>
                 </a:solidFill>
                 <a:latin typeface="Segoe UI"/>
               </a:rPr>
-              <a:t>REAL SAMPLE</a:t>
-            </a:r>
-          </a:p>
-        </p:txBody>
-      </p:sp>
-      <p:sp>
-        <p:nvSpPr>
-          <p:cNvPr id="13" name="TextBox 12"/>
+              <a:t>•  the right panel is FAKE minus REAL — exactly where the swap created new evidence.</a:t>
+            </a:r>
+          </a:p>
+        </p:txBody>
+      </p:sp>
+      <p:graphicFrame>
+        <p:nvGraphicFramePr>
+          <p:cNvPr id="8" name="Table 7"/>
+          <p:cNvGraphicFramePr>
+            <a:graphicFrameLocks noGrp="1"/>
+          </p:cNvGraphicFramePr>
+          <p:nvPr/>
+        </p:nvGraphicFramePr>
+        <p:xfrm>
+          <a:off x="6172200" y="4700016"/>
+          <a:ext cx="5449822" cy="1234440"/>
+        </p:xfrm>
+        <a:graphic>
+          <a:graphicData uri="http://schemas.openxmlformats.org/drawingml/2006/table">
+            <a:tbl>
+              <a:tblPr firstRow="1" bandRow="1">
+                <a:tableStyleId>{5C22544A-7EE6-4342-B048-85BDC9FD1C3A}</a:tableStyleId>
+              </a:tblPr>
+              <a:tblGrid>
+                <a:gridCol w="2199051"/>
+                <a:gridCol w="1051720"/>
+                <a:gridCol w="1051720"/>
+                <a:gridCol w="1147331"/>
+              </a:tblGrid>
+              <a:tr h="246888">
+                <a:tc>
+                  <a:txBody>
+                    <a:bodyPr/>
+                    <a:lstStyle/>
+                    <a:p>
+                      <a:pPr algn="l"/>
+                      <a:r>
+                        <a:rPr sz="1100" b="1">
+                          <a:solidFill>
+                            <a:srgbClr val="FFFFFF"/>
+                          </a:solidFill>
+                          <a:latin typeface="Segoe UI"/>
+                        </a:rPr>
+                        <a:t>zone (area-normalised)</a:t>
+                      </a:r>
+                    </a:p>
+                  </a:txBody>
+                  <a:tcPr marL="54864" marR="54864" marT="9144" marB="9144">
+                    <a:solidFill>
+                      <a:srgbClr val="2E6FD9"/>
+                    </a:solidFill>
+                  </a:tcPr>
+                </a:tc>
+                <a:tc>
+                  <a:txBody>
+                    <a:bodyPr/>
+                    <a:lstStyle/>
+                    <a:p>
+                      <a:pPr algn="ctr"/>
+                      <a:r>
+                        <a:rPr sz="1100" b="1">
+                          <a:solidFill>
+                            <a:srgbClr val="FFFFFF"/>
+                          </a:solidFill>
+                          <a:latin typeface="Segoe UI"/>
+                        </a:rPr>
+                        <a:t>REAL</a:t>
+                      </a:r>
+                    </a:p>
+                  </a:txBody>
+                  <a:tcPr marL="54864" marR="54864" marT="9144" marB="9144">
+                    <a:solidFill>
+                      <a:srgbClr val="2E6FD9"/>
+                    </a:solidFill>
+                  </a:tcPr>
+                </a:tc>
+                <a:tc>
+                  <a:txBody>
+                    <a:bodyPr/>
+                    <a:lstStyle/>
+                    <a:p>
+                      <a:pPr algn="ctr"/>
+                      <a:r>
+                        <a:rPr sz="1100" b="1">
+                          <a:solidFill>
+                            <a:srgbClr val="FFFFFF"/>
+                          </a:solidFill>
+                          <a:latin typeface="Segoe UI"/>
+                        </a:rPr>
+                        <a:t>FAKE</a:t>
+                      </a:r>
+                    </a:p>
+                  </a:txBody>
+                  <a:tcPr marL="54864" marR="54864" marT="9144" marB="9144">
+                    <a:solidFill>
+                      <a:srgbClr val="2E6FD9"/>
+                    </a:solidFill>
+                  </a:tcPr>
+                </a:tc>
+                <a:tc>
+                  <a:txBody>
+                    <a:bodyPr/>
+                    <a:lstStyle/>
+                    <a:p>
+                      <a:pPr algn="ctr"/>
+                      <a:r>
+                        <a:rPr sz="1100" b="1">
+                          <a:solidFill>
+                            <a:srgbClr val="FFFFFF"/>
+                          </a:solidFill>
+                          <a:latin typeface="Segoe UI"/>
+                        </a:rPr>
+                        <a:t>change</a:t>
+                      </a:r>
+                    </a:p>
+                  </a:txBody>
+                  <a:tcPr marL="54864" marR="54864" marT="9144" marB="9144">
+                    <a:solidFill>
+                      <a:srgbClr val="2E6FD9"/>
+                    </a:solidFill>
+                  </a:tcPr>
+                </a:tc>
+              </a:tr>
+              <a:tr h="246888">
+                <a:tc>
+                  <a:txBody>
+                    <a:bodyPr/>
+                    <a:lstStyle/>
+                    <a:p>
+                      <a:pPr algn="l"/>
+                      <a:r>
+                        <a:rPr sz="1100" b="0">
+                          <a:solidFill>
+                            <a:srgbClr val="1C1C24"/>
+                          </a:solidFill>
+                          <a:latin typeface="Segoe UI"/>
+                        </a:rPr>
+                        <a:t>eyes</a:t>
+                      </a:r>
+                    </a:p>
+                  </a:txBody>
+                  <a:tcPr marL="54864" marR="54864" marT="9144" marB="9144">
+                    <a:solidFill>
+                      <a:srgbClr val="F2F4F8"/>
+                    </a:solidFill>
+                  </a:tcPr>
+                </a:tc>
+                <a:tc>
+                  <a:txBody>
+                    <a:bodyPr/>
+                    <a:lstStyle/>
+                    <a:p>
+                      <a:pPr algn="ctr"/>
+                      <a:r>
+                        <a:rPr sz="1100" b="0">
+                          <a:solidFill>
+                            <a:srgbClr val="1C1C24"/>
+                          </a:solidFill>
+                          <a:latin typeface="Segoe UI"/>
+                        </a:rPr>
+                        <a:t>0.0150</a:t>
+                      </a:r>
+                    </a:p>
+                  </a:txBody>
+                  <a:tcPr marL="54864" marR="54864" marT="9144" marB="9144">
+                    <a:solidFill>
+                      <a:srgbClr val="F2F4F8"/>
+                    </a:solidFill>
+                  </a:tcPr>
+                </a:tc>
+                <a:tc>
+                  <a:txBody>
+                    <a:bodyPr/>
+                    <a:lstStyle/>
+                    <a:p>
+                      <a:pPr algn="ctr"/>
+                      <a:r>
+                        <a:rPr sz="1100" b="0">
+                          <a:solidFill>
+                            <a:srgbClr val="1C1C24"/>
+                          </a:solidFill>
+                          <a:latin typeface="Segoe UI"/>
+                        </a:rPr>
+                        <a:t>0.0399</a:t>
+                      </a:r>
+                    </a:p>
+                  </a:txBody>
+                  <a:tcPr marL="54864" marR="54864" marT="9144" marB="9144">
+                    <a:solidFill>
+                      <a:srgbClr val="F2F4F8"/>
+                    </a:solidFill>
+                  </a:tcPr>
+                </a:tc>
+                <a:tc>
+                  <a:txBody>
+                    <a:bodyPr/>
+                    <a:lstStyle/>
+                    <a:p>
+                      <a:pPr algn="ctr"/>
+                      <a:r>
+                        <a:rPr sz="1100" b="0">
+                          <a:solidFill>
+                            <a:srgbClr val="1C1C24"/>
+                          </a:solidFill>
+                          <a:latin typeface="Segoe UI"/>
+                        </a:rPr>
+                        <a:t>+0.0250</a:t>
+                      </a:r>
+                    </a:p>
+                  </a:txBody>
+                  <a:tcPr marL="54864" marR="54864" marT="9144" marB="9144">
+                    <a:solidFill>
+                      <a:srgbClr val="F2F4F8"/>
+                    </a:solidFill>
+                  </a:tcPr>
+                </a:tc>
+              </a:tr>
+              <a:tr h="246888">
+                <a:tc>
+                  <a:txBody>
+                    <a:bodyPr/>
+                    <a:lstStyle/>
+                    <a:p>
+                      <a:pPr algn="l"/>
+                      <a:r>
+                        <a:rPr sz="1100" b="0">
+                          <a:solidFill>
+                            <a:srgbClr val="1C1C24"/>
+                          </a:solidFill>
+                          <a:latin typeface="Segoe UI"/>
+                        </a:rPr>
+                        <a:t>nose</a:t>
+                      </a:r>
+                    </a:p>
+                  </a:txBody>
+                  <a:tcPr marL="54864" marR="54864" marT="9144" marB="9144">
+                    <a:solidFill>
+                      <a:srgbClr val="FFFFFF"/>
+                    </a:solidFill>
+                  </a:tcPr>
+                </a:tc>
+                <a:tc>
+                  <a:txBody>
+                    <a:bodyPr/>
+                    <a:lstStyle/>
+                    <a:p>
+                      <a:pPr algn="ctr"/>
+                      <a:r>
+                        <a:rPr sz="1100" b="0">
+                          <a:solidFill>
+                            <a:srgbClr val="1C1C24"/>
+                          </a:solidFill>
+                          <a:latin typeface="Segoe UI"/>
+                        </a:rPr>
+                        <a:t>0.0342</a:t>
+                      </a:r>
+                    </a:p>
+                  </a:txBody>
+                  <a:tcPr marL="54864" marR="54864" marT="9144" marB="9144">
+                    <a:solidFill>
+                      <a:srgbClr val="FFFFFF"/>
+                    </a:solidFill>
+                  </a:tcPr>
+                </a:tc>
+                <a:tc>
+                  <a:txBody>
+                    <a:bodyPr/>
+                    <a:lstStyle/>
+                    <a:p>
+                      <a:pPr algn="ctr"/>
+                      <a:r>
+                        <a:rPr sz="1100" b="0">
+                          <a:solidFill>
+                            <a:srgbClr val="1C1C24"/>
+                          </a:solidFill>
+                          <a:latin typeface="Segoe UI"/>
+                        </a:rPr>
+                        <a:t>0.0539</a:t>
+                      </a:r>
+                    </a:p>
+                  </a:txBody>
+                  <a:tcPr marL="54864" marR="54864" marT="9144" marB="9144">
+                    <a:solidFill>
+                      <a:srgbClr val="FFFFFF"/>
+                    </a:solidFill>
+                  </a:tcPr>
+                </a:tc>
+                <a:tc>
+                  <a:txBody>
+                    <a:bodyPr/>
+                    <a:lstStyle/>
+                    <a:p>
+                      <a:pPr algn="ctr"/>
+                      <a:r>
+                        <a:rPr sz="1100" b="0">
+                          <a:solidFill>
+                            <a:srgbClr val="1C1C24"/>
+                          </a:solidFill>
+                          <a:latin typeface="Segoe UI"/>
+                        </a:rPr>
+                        <a:t>+0.0197</a:t>
+                      </a:r>
+                    </a:p>
+                  </a:txBody>
+                  <a:tcPr marL="54864" marR="54864" marT="9144" marB="9144">
+                    <a:solidFill>
+                      <a:srgbClr val="FFFFFF"/>
+                    </a:solidFill>
+                  </a:tcPr>
+                </a:tc>
+              </a:tr>
+              <a:tr h="246888">
+                <a:tc>
+                  <a:txBody>
+                    <a:bodyPr/>
+                    <a:lstStyle/>
+                    <a:p>
+                      <a:pPr algn="l"/>
+                      <a:r>
+                        <a:rPr sz="1100" b="0">
+                          <a:solidFill>
+                            <a:srgbClr val="1C1C24"/>
+                          </a:solidFill>
+                          <a:latin typeface="Segoe UI"/>
+                        </a:rPr>
+                        <a:t>mouth</a:t>
+                      </a:r>
+                    </a:p>
+                  </a:txBody>
+                  <a:tcPr marL="54864" marR="54864" marT="9144" marB="9144">
+                    <a:solidFill>
+                      <a:srgbClr val="F2F4F8"/>
+                    </a:solidFill>
+                  </a:tcPr>
+                </a:tc>
+                <a:tc>
+                  <a:txBody>
+                    <a:bodyPr/>
+                    <a:lstStyle/>
+                    <a:p>
+                      <a:pPr algn="ctr"/>
+                      <a:r>
+                        <a:rPr sz="1100" b="0">
+                          <a:solidFill>
+                            <a:srgbClr val="1C1C24"/>
+                          </a:solidFill>
+                          <a:latin typeface="Segoe UI"/>
+                        </a:rPr>
+                        <a:t>0.0244</a:t>
+                      </a:r>
+                    </a:p>
+                  </a:txBody>
+                  <a:tcPr marL="54864" marR="54864" marT="9144" marB="9144">
+                    <a:solidFill>
+                      <a:srgbClr val="F2F4F8"/>
+                    </a:solidFill>
+                  </a:tcPr>
+                </a:tc>
+                <a:tc>
+                  <a:txBody>
+                    <a:bodyPr/>
+                    <a:lstStyle/>
+                    <a:p>
+                      <a:pPr algn="ctr"/>
+                      <a:r>
+                        <a:rPr sz="1100" b="0">
+                          <a:solidFill>
+                            <a:srgbClr val="1C1C24"/>
+                          </a:solidFill>
+                          <a:latin typeface="Segoe UI"/>
+                        </a:rPr>
+                        <a:t>0.0237</a:t>
+                      </a:r>
+                    </a:p>
+                  </a:txBody>
+                  <a:tcPr marL="54864" marR="54864" marT="9144" marB="9144">
+                    <a:solidFill>
+                      <a:srgbClr val="F2F4F8"/>
+                    </a:solidFill>
+                  </a:tcPr>
+                </a:tc>
+                <a:tc>
+                  <a:txBody>
+                    <a:bodyPr/>
+                    <a:lstStyle/>
+                    <a:p>
+                      <a:pPr algn="ctr"/>
+                      <a:r>
+                        <a:rPr sz="1100" b="0">
+                          <a:solidFill>
+                            <a:srgbClr val="1C1C24"/>
+                          </a:solidFill>
+                          <a:latin typeface="Segoe UI"/>
+                        </a:rPr>
+                        <a:t>-0.0007</a:t>
+                      </a:r>
+                    </a:p>
+                  </a:txBody>
+                  <a:tcPr marL="54864" marR="54864" marT="9144" marB="9144">
+                    <a:solidFill>
+                      <a:srgbClr val="F2F4F8"/>
+                    </a:solidFill>
+                  </a:tcPr>
+                </a:tc>
+              </a:tr>
+              <a:tr h="246888">
+                <a:tc>
+                  <a:txBody>
+                    <a:bodyPr/>
+                    <a:lstStyle/>
+                    <a:p>
+                      <a:pPr algn="l"/>
+                      <a:r>
+                        <a:rPr sz="1100" b="0">
+                          <a:solidFill>
+                            <a:srgbClr val="1C1C24"/>
+                          </a:solidFill>
+                          <a:latin typeface="Segoe UI"/>
+                        </a:rPr>
+                        <a:t>jaw / contour</a:t>
+                      </a:r>
+                    </a:p>
+                  </a:txBody>
+                  <a:tcPr marL="54864" marR="54864" marT="9144" marB="9144">
+                    <a:solidFill>
+                      <a:srgbClr val="FFFFFF"/>
+                    </a:solidFill>
+                  </a:tcPr>
+                </a:tc>
+                <a:tc>
+                  <a:txBody>
+                    <a:bodyPr/>
+                    <a:lstStyle/>
+                    <a:p>
+                      <a:pPr algn="ctr"/>
+                      <a:r>
+                        <a:rPr sz="1100" b="0">
+                          <a:solidFill>
+                            <a:srgbClr val="1C1C24"/>
+                          </a:solidFill>
+                          <a:latin typeface="Segoe UI"/>
+                        </a:rPr>
+                        <a:t>0.0488</a:t>
+                      </a:r>
+                    </a:p>
+                  </a:txBody>
+                  <a:tcPr marL="54864" marR="54864" marT="9144" marB="9144">
+                    <a:solidFill>
+                      <a:srgbClr val="FFFFFF"/>
+                    </a:solidFill>
+                  </a:tcPr>
+                </a:tc>
+                <a:tc>
+                  <a:txBody>
+                    <a:bodyPr/>
+                    <a:lstStyle/>
+                    <a:p>
+                      <a:pPr algn="ctr"/>
+                      <a:r>
+                        <a:rPr sz="1100" b="0">
+                          <a:solidFill>
+                            <a:srgbClr val="1C1C24"/>
+                          </a:solidFill>
+                          <a:latin typeface="Segoe UI"/>
+                        </a:rPr>
+                        <a:t>0.0306</a:t>
+                      </a:r>
+                    </a:p>
+                  </a:txBody>
+                  <a:tcPr marL="54864" marR="54864" marT="9144" marB="9144">
+                    <a:solidFill>
+                      <a:srgbClr val="FFFFFF"/>
+                    </a:solidFill>
+                  </a:tcPr>
+                </a:tc>
+                <a:tc>
+                  <a:txBody>
+                    <a:bodyPr/>
+                    <a:lstStyle/>
+                    <a:p>
+                      <a:pPr algn="ctr"/>
+                      <a:r>
+                        <a:rPr sz="1100" b="0">
+                          <a:solidFill>
+                            <a:srgbClr val="1C1C24"/>
+                          </a:solidFill>
+                          <a:latin typeface="Segoe UI"/>
+                        </a:rPr>
+                        <a:t>-0.0182</a:t>
+                      </a:r>
+                    </a:p>
+                  </a:txBody>
+                  <a:tcPr marL="54864" marR="54864" marT="9144" marB="9144">
+                    <a:solidFill>
+                      <a:srgbClr val="FFFFFF"/>
+                    </a:solidFill>
+                  </a:tcPr>
+                </a:tc>
+              </a:tr>
+            </a:tbl>
+          </a:graphicData>
+        </a:graphic>
+      </p:graphicFrame>
+      <p:sp>
+        <p:nvSpPr>
+          <p:cNvPr id="9" name="TextBox 8"/>
           <p:cNvSpPr txBox="1"/>
           <p:nvPr/>
         </p:nvSpPr>
         <p:spPr>
           <a:xfrm>
-            <a:off x="8275319" y="3255264"/>
-            <a:ext cx="3163824" cy="384048"/>
-          </a:xfrm>
-          <a:prstGeom prst="rect">
-            <a:avLst/>
-          </a:prstGeom>
-          <a:noFill/>
-        </p:spPr>
-        <p:txBody>
-          <a:bodyPr wrap="square" lIns="0" rIns="0" tIns="0" bIns="0">
-            <a:spAutoFit/>
-          </a:bodyPr>
-          <a:lstStyle/>
-          <a:p>
-            <a:pPr algn="l">
-              <a:lnSpc>
-                <a:spcPct val="114000"/>
-              </a:lnSpc>
-              <a:spcAft>
-                <a:spcPts val="500"/>
-              </a:spcAft>
-            </a:pPr>
-            <a:r>
-              <a:rPr sz="1600" b="1" i="0">
-                <a:solidFill>
-                  <a:srgbClr val="2E6FD9"/>
-                </a:solidFill>
-                <a:latin typeface="Segoe UI"/>
-              </a:rPr>
-              <a:t>both sufficient</a:t>
-            </a:r>
-          </a:p>
-        </p:txBody>
-      </p:sp>
-      <p:sp>
-        <p:nvSpPr>
-          <p:cNvPr id="14" name="TextBox 13"/>
-          <p:cNvSpPr txBox="1"/>
-          <p:nvPr/>
-        </p:nvSpPr>
-        <p:spPr>
-          <a:xfrm>
-            <a:off x="8275319" y="3694176"/>
-            <a:ext cx="3163824" cy="256032"/>
-          </a:xfrm>
-          <a:prstGeom prst="rect">
-            <a:avLst/>
-          </a:prstGeom>
-          <a:noFill/>
-        </p:spPr>
-        <p:txBody>
-          <a:bodyPr wrap="square" lIns="0" rIns="0" tIns="0" bIns="0">
-            <a:spAutoFit/>
-          </a:bodyPr>
-          <a:lstStyle/>
-          <a:p>
-            <a:pPr algn="l">
-              <a:lnSpc>
-                <a:spcPct val="118000"/>
-              </a:lnSpc>
-              <a:spcAft>
-                <a:spcPts val="500"/>
-              </a:spcAft>
-            </a:pPr>
-            <a:r>
-              <a:rPr sz="1050" b="0" i="0">
-                <a:solidFill>
-                  <a:srgbClr val="1C1C24"/>
-                </a:solidFill>
-                <a:latin typeface="Segoe UI"/>
-              </a:rPr>
-              <a:t>S alone 0.469  ·  T alone 0.411</a:t>
-            </a:r>
-          </a:p>
-        </p:txBody>
-      </p:sp>
-      <p:sp>
-        <p:nvSpPr>
-          <p:cNvPr id="15" name="TextBox 14"/>
-          <p:cNvSpPr txBox="1"/>
-          <p:nvPr/>
-        </p:nvSpPr>
-        <p:spPr>
-          <a:xfrm>
-            <a:off x="8092440" y="4224528"/>
-            <a:ext cx="3529584" cy="822960"/>
+            <a:off x="6172200" y="6025896"/>
+            <a:ext cx="5449824" cy="548640"/>
           </a:xfrm>
           <a:prstGeom prst="rect">
             <a:avLst/>
@@ -16742,106 +18770,7 @@
                 </a:solidFill>
                 <a:latin typeface="Segoe UI"/>
               </a:rPr>
-              <a:t>Per-clip branch agreement:</a:t>
-            </a:r>
-          </a:p>
-          <a:p>
-            <a:pPr algn="l">
-              <a:lnSpc>
-                <a:spcPct val="122000"/>
-              </a:lnSpc>
-              <a:spcAft>
-                <a:spcPts val="500"/>
-              </a:spcAft>
-            </a:pPr>
-            <a:r>
-              <a:rPr sz="1150" b="0" i="0">
-                <a:solidFill>
-                  <a:srgbClr val="1C1C24"/>
-                </a:solidFill>
-                <a:latin typeface="Segoe UI"/>
-              </a:rPr>
-              <a:t>•  fake: 100%     - real: 87%</a:t>
-            </a:r>
-          </a:p>
-        </p:txBody>
-      </p:sp>
-      <p:sp>
-        <p:nvSpPr>
-          <p:cNvPr id="16" name="TextBox 15"/>
-          <p:cNvSpPr txBox="1"/>
-          <p:nvPr/>
-        </p:nvSpPr>
-        <p:spPr>
-          <a:xfrm>
-            <a:off x="566928" y="4134058"/>
-            <a:ext cx="7315200" cy="1463040"/>
-          </a:xfrm>
-          <a:prstGeom prst="rect">
-            <a:avLst/>
-          </a:prstGeom>
-          <a:noFill/>
-        </p:spPr>
-        <p:txBody>
-          <a:bodyPr wrap="square" lIns="0" rIns="0" tIns="0" bIns="0">
-            <a:spAutoFit/>
-          </a:bodyPr>
-          <a:lstStyle/>
-          <a:p>
-            <a:pPr algn="l">
-              <a:lnSpc>
-                <a:spcPct val="126000"/>
-              </a:lnSpc>
-              <a:spcAft>
-                <a:spcPts val="500"/>
-              </a:spcAft>
-            </a:pPr>
-            <a:r>
-              <a:rPr sz="1150" b="0" i="0">
-                <a:solidFill>
-                  <a:srgbClr val="1C1C24"/>
-                </a:solidFill>
-                <a:latin typeface="Segoe UI"/>
-              </a:rPr>
-              <a:t>•  On clean video either branch alone already reaches the correct verdict — the two are redundant here, not complementary.</a:t>
-            </a:r>
-          </a:p>
-          <a:p>
-            <a:pPr algn="l">
-              <a:lnSpc>
-                <a:spcPct val="126000"/>
-              </a:lnSpc>
-              <a:spcAft>
-                <a:spcPts val="500"/>
-              </a:spcAft>
-            </a:pPr>
-            <a:r>
-              <a:rPr sz="1150" b="0" i="0">
-                <a:solidFill>
-                  <a:srgbClr val="1C1C24"/>
-                </a:solidFill>
-                <a:latin typeface="Segoe UI"/>
-              </a:rPr>
-              <a:t>•  Fusion still adds confidence: the fake rises 0.91 → 0.93.</a:t>
-            </a:r>
-          </a:p>
-          <a:p>
-            <a:pPr algn="l">
-              <a:lnSpc>
-                <a:spcPct val="126000"/>
-              </a:lnSpc>
-              <a:spcAft>
-                <a:spcPts val="500"/>
-              </a:spcAft>
-            </a:pPr>
-            <a:r>
-              <a:rPr sz="1150" b="0" i="0">
-                <a:solidFill>
-                  <a:srgbClr val="1C1C24"/>
-                </a:solidFill>
-                <a:latin typeface="Segoe UI"/>
-              </a:rPr>
-              <a:t>•  That redundancy is exactly what breaks under degradation (next slide).</a:t>
+              <a:t>Biggest gains after the swap: eyes, nose, mouth — the same inner-face region the swap replaced.</a:t>
             </a:r>
           </a:p>
         </p:txBody>

</xml_diff>